<commit_message>
Recolour deck to the CAMP Digital brand palette
Rebuild the palette around the two tones in the CAMP logo — forest green
0F8140 and lime A9C63C — replacing the placeholder teal-green carried over
from the source deck.

- Green carries structure (titles, headers, dark backgrounds, statement bands);
  lime is reserved as the sharp accent for key figures, emphasis runs, the CTA
  band, and page numbers on dark slides
- Set the footer/cover lockup in the brand's two-tone arrangement: CAMP with the
  A in lime, DIGITAL letterspaced in lime
- Re-render the line-icon set in the brand greens
- Drop the statement band's outline, which LibreOffice rendered as a stray
  hairline along the bottom edge

Copy remains byte-identical to the source deck; verified paragraph-by-paragraph.

Co-Authored-By: Claude Opus 5 <noreply@anthropic.com>
Claude-Session: https://claude.ai/code/session_01T493Vq5jZiUELb1FcK1kBZ
</commit_message>
<xml_diff>
--- a/decks/camp-ctv/camp-ctv-redesigned.pptx
+++ b/decks/camp-ctv/camp-ctv-redesigned.pptx
@@ -1836,7 +1836,7 @@
     <p:bg>
       <p:bgPr>
         <a:solidFill>
-          <a:srgbClr val="052C21"/>
+          <a:srgbClr val="06301A"/>
         </a:solidFill>
       </p:bgPr>
     </p:bg>
@@ -1910,15 +1910,43 @@
                 <a:ea typeface="Arial" pitchFamily="34" charset="-122"/>
                 <a:cs typeface="Arial" pitchFamily="34" charset="-120"/>
               </a:rPr>
-              <a:t>CAMP</a:t>
+              <a:t>C</a:t>
             </a:r>
             <a:pPr algn="l" indent="0" marL="0">
               <a:buNone/>
             </a:pPr>
             <a:r>
+              <a:rPr lang="en-US" sz="1300" b="1" spc="117" kern="0" dirty="0">
+                <a:solidFill>
+                  <a:srgbClr val="A9C63C"/>
+                </a:solidFill>
+                <a:latin typeface="Arial" pitchFamily="34" charset="0"/>
+                <a:ea typeface="Arial" pitchFamily="34" charset="-122"/>
+                <a:cs typeface="Arial" pitchFamily="34" charset="-120"/>
+              </a:rPr>
+              <a:t>A</a:t>
+            </a:r>
+            <a:pPr algn="l" indent="0" marL="0">
+              <a:buNone/>
+            </a:pPr>
+            <a:r>
+              <a:rPr lang="en-US" sz="1300" b="1" spc="117" kern="0" dirty="0">
+                <a:solidFill>
+                  <a:srgbClr val="FFFFFF"/>
+                </a:solidFill>
+                <a:latin typeface="Arial" pitchFamily="34" charset="0"/>
+                <a:ea typeface="Arial" pitchFamily="34" charset="-122"/>
+                <a:cs typeface="Arial" pitchFamily="34" charset="-120"/>
+              </a:rPr>
+              <a:t>MP</a:t>
+            </a:r>
+            <a:pPr algn="l" indent="0" marL="0">
+              <a:buNone/>
+            </a:pPr>
+            <a:r>
               <a:rPr lang="en-US" sz="1300" spc="286" kern="0" dirty="0">
                 <a:solidFill>
-                  <a:srgbClr val="7FDCBB"/>
+                  <a:srgbClr val="A9C63C"/>
                 </a:solidFill>
                 <a:latin typeface="Arial" pitchFamily="34" charset="0"/>
                 <a:ea typeface="Arial" pitchFamily="34" charset="-122"/>
@@ -2002,7 +2030,7 @@
             <a:r>
               <a:rPr lang="en-US" sz="1300" dirty="0">
                 <a:solidFill>
-                  <a:srgbClr val="B2E5D5"/>
+                  <a:srgbClr val="D3E4A4"/>
                 </a:solidFill>
                 <a:latin typeface="Arial" pitchFamily="34" charset="0"/>
                 <a:ea typeface="Arial" pitchFamily="34" charset="-122"/>
@@ -2031,11 +2059,11 @@
             </a:avLst>
           </a:prstGeom>
           <a:solidFill>
-            <a:srgbClr val="0A3A2C"/>
+            <a:srgbClr val="0B4526"/>
           </a:solidFill>
           <a:ln w="9525">
             <a:solidFill>
-              <a:srgbClr val="16513D"/>
+              <a:srgbClr val="1A5E34"/>
             </a:solidFill>
             <a:prstDash val="solid"/>
           </a:ln>
@@ -2113,7 +2141,7 @@
             <a:r>
               <a:rPr lang="en-US" sz="1000" dirty="0">
                 <a:solidFill>
-                  <a:srgbClr val="9FC4B7"/>
+                  <a:srgbClr val="A8C09B"/>
                 </a:solidFill>
                 <a:latin typeface="Arial" pitchFamily="34" charset="0"/>
                 <a:ea typeface="Arial" pitchFamily="34" charset="-122"/>
@@ -2142,11 +2170,11 @@
             </a:avLst>
           </a:prstGeom>
           <a:solidFill>
-            <a:srgbClr val="0A3A2C"/>
+            <a:srgbClr val="0B4526"/>
           </a:solidFill>
           <a:ln w="9525">
             <a:solidFill>
-              <a:srgbClr val="16513D"/>
+              <a:srgbClr val="1A5E34"/>
             </a:solidFill>
             <a:prstDash val="solid"/>
           </a:ln>
@@ -2224,7 +2252,7 @@
             <a:r>
               <a:rPr lang="en-US" sz="1000" dirty="0">
                 <a:solidFill>
-                  <a:srgbClr val="9FC4B7"/>
+                  <a:srgbClr val="A8C09B"/>
                 </a:solidFill>
                 <a:latin typeface="Arial" pitchFamily="34" charset="0"/>
                 <a:ea typeface="Arial" pitchFamily="34" charset="-122"/>
@@ -2253,11 +2281,11 @@
             </a:avLst>
           </a:prstGeom>
           <a:solidFill>
-            <a:srgbClr val="0A3A2C"/>
+            <a:srgbClr val="0B4526"/>
           </a:solidFill>
           <a:ln w="9525">
             <a:solidFill>
-              <a:srgbClr val="16513D"/>
+              <a:srgbClr val="1A5E34"/>
             </a:solidFill>
             <a:prstDash val="solid"/>
           </a:ln>
@@ -2335,7 +2363,7 @@
             <a:r>
               <a:rPr lang="en-US" sz="1000" dirty="0">
                 <a:solidFill>
-                  <a:srgbClr val="9FC4B7"/>
+                  <a:srgbClr val="A8C09B"/>
                 </a:solidFill>
                 <a:latin typeface="Arial" pitchFamily="34" charset="0"/>
                 <a:ea typeface="Arial" pitchFamily="34" charset="-122"/>
@@ -2409,7 +2437,7 @@
             <a:r>
               <a:rPr lang="en-US" sz="2700" b="1" spc="-40" kern="0" dirty="0">
                 <a:solidFill>
-                  <a:srgbClr val="0E1F1A"/>
+                  <a:srgbClr val="0D1F14"/>
                 </a:solidFill>
                 <a:latin typeface="Arial" pitchFamily="34" charset="0"/>
                 <a:ea typeface="Arial" pitchFamily="34" charset="-122"/>
@@ -2438,7 +2466,7 @@
             </a:avLst>
           </a:prstGeom>
           <a:solidFill>
-            <a:srgbClr val="EDF7F3"/>
+            <a:srgbClr val="EEF5E4"/>
           </a:solidFill>
           <a:ln w="9525">
             <a:solidFill>
@@ -2555,7 +2583,7 @@
             <a:r>
               <a:rPr lang="en-US" sz="900" b="1" spc="110" kern="0" dirty="0">
                 <a:solidFill>
-                  <a:srgbClr val="006A49"/>
+                  <a:srgbClr val="0F8140"/>
                 </a:solidFill>
                 <a:latin typeface="Arial" pitchFamily="34" charset="0"/>
                 <a:ea typeface="Arial" pitchFamily="34" charset="-122"/>
@@ -2582,11 +2610,11 @@
             <a:avLst/>
           </a:prstGeom>
           <a:solidFill>
-            <a:srgbClr val="EDF7F3"/>
+            <a:srgbClr val="EEF5E4"/>
           </a:solidFill>
           <a:ln w="11430">
             <a:solidFill>
-              <a:srgbClr val="CDE8DE"/>
+              <a:srgbClr val="CFE2B8"/>
             </a:solidFill>
             <a:prstDash val="solid"/>
           </a:ln>
@@ -2646,7 +2674,7 @@
             <a:r>
               <a:rPr lang="en-US" sz="1200" b="1" dirty="0">
                 <a:solidFill>
-                  <a:srgbClr val="0E1F1A"/>
+                  <a:srgbClr val="0D1F14"/>
                 </a:solidFill>
                 <a:latin typeface="Arial" pitchFamily="34" charset="0"/>
                 <a:ea typeface="Arial" pitchFamily="34" charset="-122"/>
@@ -2688,7 +2716,7 @@
             <a:r>
               <a:rPr lang="en-US" sz="1050" dirty="0">
                 <a:solidFill>
-                  <a:srgbClr val="56645F"/>
+                  <a:srgbClr val="555F57"/>
                 </a:solidFill>
                 <a:latin typeface="Arial" pitchFamily="34" charset="0"/>
                 <a:ea typeface="Arial" pitchFamily="34" charset="-122"/>
@@ -2715,7 +2743,7 @@
             <a:avLst/>
           </a:prstGeom>
           <a:solidFill>
-            <a:srgbClr val="DDE7E3"/>
+            <a:srgbClr val="DEE6DE"/>
           </a:solidFill>
           <a:ln/>
         </p:spPr>
@@ -2735,11 +2763,11 @@
             <a:avLst/>
           </a:prstGeom>
           <a:solidFill>
-            <a:srgbClr val="EDF7F3"/>
+            <a:srgbClr val="EEF5E4"/>
           </a:solidFill>
           <a:ln w="11430">
             <a:solidFill>
-              <a:srgbClr val="CDE8DE"/>
+              <a:srgbClr val="CFE2B8"/>
             </a:solidFill>
             <a:prstDash val="solid"/>
           </a:ln>
@@ -2799,7 +2827,7 @@
             <a:r>
               <a:rPr lang="en-US" sz="1200" b="1" dirty="0">
                 <a:solidFill>
-                  <a:srgbClr val="0E1F1A"/>
+                  <a:srgbClr val="0D1F14"/>
                 </a:solidFill>
                 <a:latin typeface="Arial" pitchFamily="34" charset="0"/>
                 <a:ea typeface="Arial" pitchFamily="34" charset="-122"/>
@@ -2841,7 +2869,7 @@
             <a:r>
               <a:rPr lang="en-US" sz="1050" dirty="0">
                 <a:solidFill>
-                  <a:srgbClr val="56645F"/>
+                  <a:srgbClr val="555F57"/>
                 </a:solidFill>
                 <a:latin typeface="Arial" pitchFamily="34" charset="0"/>
                 <a:ea typeface="Arial" pitchFamily="34" charset="-122"/>
@@ -2868,7 +2896,7 @@
             <a:avLst/>
           </a:prstGeom>
           <a:solidFill>
-            <a:srgbClr val="DDE7E3"/>
+            <a:srgbClr val="DEE6DE"/>
           </a:solidFill>
           <a:ln/>
         </p:spPr>
@@ -2888,11 +2916,11 @@
             <a:avLst/>
           </a:prstGeom>
           <a:solidFill>
-            <a:srgbClr val="EDF7F3"/>
+            <a:srgbClr val="EEF5E4"/>
           </a:solidFill>
           <a:ln w="11430">
             <a:solidFill>
-              <a:srgbClr val="CDE8DE"/>
+              <a:srgbClr val="CFE2B8"/>
             </a:solidFill>
             <a:prstDash val="solid"/>
           </a:ln>
@@ -2952,7 +2980,7 @@
             <a:r>
               <a:rPr lang="en-US" sz="1200" b="1" dirty="0">
                 <a:solidFill>
-                  <a:srgbClr val="0E1F1A"/>
+                  <a:srgbClr val="0D1F14"/>
                 </a:solidFill>
                 <a:latin typeface="Arial" pitchFamily="34" charset="0"/>
                 <a:ea typeface="Arial" pitchFamily="34" charset="-122"/>
@@ -2994,7 +3022,7 @@
             <a:r>
               <a:rPr lang="en-US" sz="1050" dirty="0">
                 <a:solidFill>
-                  <a:srgbClr val="56645F"/>
+                  <a:srgbClr val="555F57"/>
                 </a:solidFill>
                 <a:latin typeface="Arial" pitchFamily="34" charset="0"/>
                 <a:ea typeface="Arial" pitchFamily="34" charset="-122"/>
@@ -3023,7 +3051,7 @@
             </a:avLst>
           </a:prstGeom>
           <a:solidFill>
-            <a:srgbClr val="EDF7F3"/>
+            <a:srgbClr val="EEF5E4"/>
           </a:solidFill>
           <a:ln w="9525">
             <a:solidFill>
@@ -3084,7 +3112,7 @@
             <a:r>
               <a:rPr lang="en-US" sz="900" b="1" spc="110" kern="0" dirty="0">
                 <a:solidFill>
-                  <a:srgbClr val="006A49"/>
+                  <a:srgbClr val="0F8140"/>
                 </a:solidFill>
                 <a:latin typeface="Arial" pitchFamily="34" charset="0"/>
                 <a:ea typeface="Arial" pitchFamily="34" charset="-122"/>
@@ -3111,11 +3139,11 @@
             <a:avLst/>
           </a:prstGeom>
           <a:solidFill>
-            <a:srgbClr val="EDF7F3"/>
+            <a:srgbClr val="EEF5E4"/>
           </a:solidFill>
           <a:ln w="11430">
             <a:solidFill>
-              <a:srgbClr val="CDE8DE"/>
+              <a:srgbClr val="CFE2B8"/>
             </a:solidFill>
             <a:prstDash val="solid"/>
           </a:ln>
@@ -3175,7 +3203,7 @@
             <a:r>
               <a:rPr lang="en-US" sz="1200" b="1" dirty="0">
                 <a:solidFill>
-                  <a:srgbClr val="0E1F1A"/>
+                  <a:srgbClr val="0D1F14"/>
                 </a:solidFill>
                 <a:latin typeface="Arial" pitchFamily="34" charset="0"/>
                 <a:ea typeface="Arial" pitchFamily="34" charset="-122"/>
@@ -3217,7 +3245,7 @@
             <a:r>
               <a:rPr lang="en-US" sz="1050" dirty="0">
                 <a:solidFill>
-                  <a:srgbClr val="56645F"/>
+                  <a:srgbClr val="555F57"/>
                 </a:solidFill>
                 <a:latin typeface="Arial" pitchFamily="34" charset="0"/>
                 <a:ea typeface="Arial" pitchFamily="34" charset="-122"/>
@@ -3244,7 +3272,7 @@
             <a:avLst/>
           </a:prstGeom>
           <a:solidFill>
-            <a:srgbClr val="DDE7E3"/>
+            <a:srgbClr val="DEE6DE"/>
           </a:solidFill>
           <a:ln/>
         </p:spPr>
@@ -3264,11 +3292,11 @@
             <a:avLst/>
           </a:prstGeom>
           <a:solidFill>
-            <a:srgbClr val="EDF7F3"/>
+            <a:srgbClr val="EEF5E4"/>
           </a:solidFill>
           <a:ln w="11430">
             <a:solidFill>
-              <a:srgbClr val="CDE8DE"/>
+              <a:srgbClr val="CFE2B8"/>
             </a:solidFill>
             <a:prstDash val="solid"/>
           </a:ln>
@@ -3328,7 +3356,7 @@
             <a:r>
               <a:rPr lang="en-US" sz="1200" b="1" dirty="0">
                 <a:solidFill>
-                  <a:srgbClr val="0E1F1A"/>
+                  <a:srgbClr val="0D1F14"/>
                 </a:solidFill>
                 <a:latin typeface="Arial" pitchFamily="34" charset="0"/>
                 <a:ea typeface="Arial" pitchFamily="34" charset="-122"/>
@@ -3370,7 +3398,7 @@
             <a:r>
               <a:rPr lang="en-US" sz="1050" dirty="0">
                 <a:solidFill>
-                  <a:srgbClr val="56645F"/>
+                  <a:srgbClr val="555F57"/>
                 </a:solidFill>
                 <a:latin typeface="Arial" pitchFamily="34" charset="0"/>
                 <a:ea typeface="Arial" pitchFamily="34" charset="-122"/>
@@ -3397,7 +3425,7 @@
             <a:avLst/>
           </a:prstGeom>
           <a:solidFill>
-            <a:srgbClr val="DDE7E3"/>
+            <a:srgbClr val="DEE6DE"/>
           </a:solidFill>
           <a:ln/>
         </p:spPr>
@@ -3417,11 +3445,11 @@
             <a:avLst/>
           </a:prstGeom>
           <a:solidFill>
-            <a:srgbClr val="EDF7F3"/>
+            <a:srgbClr val="EEF5E4"/>
           </a:solidFill>
           <a:ln w="11430">
             <a:solidFill>
-              <a:srgbClr val="CDE8DE"/>
+              <a:srgbClr val="CFE2B8"/>
             </a:solidFill>
             <a:prstDash val="solid"/>
           </a:ln>
@@ -3481,7 +3509,7 @@
             <a:r>
               <a:rPr lang="en-US" sz="1200" b="1" dirty="0">
                 <a:solidFill>
-                  <a:srgbClr val="0E1F1A"/>
+                  <a:srgbClr val="0D1F14"/>
                 </a:solidFill>
                 <a:latin typeface="Arial" pitchFamily="34" charset="0"/>
                 <a:ea typeface="Arial" pitchFamily="34" charset="-122"/>
@@ -3523,7 +3551,7 @@
             <a:r>
               <a:rPr lang="en-US" sz="1050" dirty="0">
                 <a:solidFill>
-                  <a:srgbClr val="56645F"/>
+                  <a:srgbClr val="555F57"/>
                 </a:solidFill>
                 <a:latin typeface="Arial" pitchFamily="34" charset="0"/>
                 <a:ea typeface="Arial" pitchFamily="34" charset="-122"/>
@@ -3562,21 +3590,49 @@
             <a:r>
               <a:rPr lang="en-US" sz="800" b="1" spc="72" kern="0" dirty="0">
                 <a:solidFill>
-                  <a:srgbClr val="0E1F1A"/>
-                </a:solidFill>
-                <a:latin typeface="Arial" pitchFamily="34" charset="0"/>
-                <a:ea typeface="Arial" pitchFamily="34" charset="-122"/>
-                <a:cs typeface="Arial" pitchFamily="34" charset="-120"/>
-              </a:rPr>
-              <a:t>CAMP</a:t>
+                  <a:srgbClr val="0F8140"/>
+                </a:solidFill>
+                <a:latin typeface="Arial" pitchFamily="34" charset="0"/>
+                <a:ea typeface="Arial" pitchFamily="34" charset="-122"/>
+                <a:cs typeface="Arial" pitchFamily="34" charset="-120"/>
+              </a:rPr>
+              <a:t>C</a:t>
             </a:r>
             <a:pPr algn="l" indent="0" marL="0">
               <a:buNone/>
             </a:pPr>
             <a:r>
+              <a:rPr lang="en-US" sz="800" b="1" spc="72" kern="0" dirty="0">
+                <a:solidFill>
+                  <a:srgbClr val="A9C63C"/>
+                </a:solidFill>
+                <a:latin typeface="Arial" pitchFamily="34" charset="0"/>
+                <a:ea typeface="Arial" pitchFamily="34" charset="-122"/>
+                <a:cs typeface="Arial" pitchFamily="34" charset="-120"/>
+              </a:rPr>
+              <a:t>A</a:t>
+            </a:r>
+            <a:pPr algn="l" indent="0" marL="0">
+              <a:buNone/>
+            </a:pPr>
+            <a:r>
+              <a:rPr lang="en-US" sz="800" b="1" spc="72" kern="0" dirty="0">
+                <a:solidFill>
+                  <a:srgbClr val="0F8140"/>
+                </a:solidFill>
+                <a:latin typeface="Arial" pitchFamily="34" charset="0"/>
+                <a:ea typeface="Arial" pitchFamily="34" charset="-122"/>
+                <a:cs typeface="Arial" pitchFamily="34" charset="-120"/>
+              </a:rPr>
+              <a:t>MP</a:t>
+            </a:r>
+            <a:pPr algn="l" indent="0" marL="0">
+              <a:buNone/>
+            </a:pPr>
+            <a:r>
               <a:rPr lang="en-US" sz="800" spc="176" kern="0" dirty="0">
                 <a:solidFill>
-                  <a:srgbClr val="006A49"/>
+                  <a:srgbClr val="A9C63C"/>
                 </a:solidFill>
                 <a:latin typeface="Arial" pitchFamily="34" charset="0"/>
                 <a:ea typeface="Arial" pitchFamily="34" charset="-122"/>
@@ -3615,7 +3671,7 @@
             <a:r>
               <a:rPr lang="en-US" sz="800" b="1" spc="120" kern="0" dirty="0">
                 <a:solidFill>
-                  <a:srgbClr val="006A49"/>
+                  <a:srgbClr val="0F8140"/>
                 </a:solidFill>
                 <a:latin typeface="Arial" pitchFamily="34" charset="0"/>
                 <a:ea typeface="Arial" pitchFamily="34" charset="-122"/>
@@ -3689,7 +3745,7 @@
             <a:r>
               <a:rPr lang="en-US" sz="2700" b="1" spc="-40" kern="0" dirty="0">
                 <a:solidFill>
-                  <a:srgbClr val="0E1F1A"/>
+                  <a:srgbClr val="0D1F14"/>
                 </a:solidFill>
                 <a:latin typeface="Arial" pitchFamily="34" charset="0"/>
                 <a:ea typeface="Arial" pitchFamily="34" charset="-122"/>
@@ -3718,11 +3774,11 @@
             </a:avLst>
           </a:prstGeom>
           <a:solidFill>
-            <a:srgbClr val="F3F7F5"/>
+            <a:srgbClr val="F4F7F2"/>
           </a:solidFill>
           <a:ln w="9525">
             <a:solidFill>
-              <a:srgbClr val="DDE7E3"/>
+              <a:srgbClr val="DEE6DE"/>
             </a:solidFill>
             <a:prstDash val="solid"/>
           </a:ln>
@@ -3747,7 +3803,7 @@
           </a:solidFill>
           <a:ln w="28575">
             <a:solidFill>
-              <a:srgbClr val="006A49"/>
+              <a:srgbClr val="0F8140"/>
             </a:solidFill>
             <a:prstDash val="solid"/>
           </a:ln>
@@ -3811,7 +3867,7 @@
             <a:r>
               <a:rPr lang="en-US" sz="1150" b="1" dirty="0">
                 <a:solidFill>
-                  <a:srgbClr val="0E1F1A"/>
+                  <a:srgbClr val="0D1F14"/>
                 </a:solidFill>
                 <a:latin typeface="Arial" pitchFamily="34" charset="0"/>
                 <a:ea typeface="Arial" pitchFamily="34" charset="-122"/>
@@ -3866,7 +3922,7 @@
           </a:solidFill>
           <a:ln w="28575">
             <a:solidFill>
-              <a:srgbClr val="006A49"/>
+              <a:srgbClr val="0F8140"/>
             </a:solidFill>
             <a:prstDash val="solid"/>
           </a:ln>
@@ -3930,7 +3986,7 @@
             <a:r>
               <a:rPr lang="en-US" sz="1150" b="1" dirty="0">
                 <a:solidFill>
-                  <a:srgbClr val="0E1F1A"/>
+                  <a:srgbClr val="0D1F14"/>
                 </a:solidFill>
                 <a:latin typeface="Arial" pitchFamily="34" charset="0"/>
                 <a:ea typeface="Arial" pitchFamily="34" charset="-122"/>
@@ -3985,7 +4041,7 @@
           </a:solidFill>
           <a:ln w="28575">
             <a:solidFill>
-              <a:srgbClr val="006A49"/>
+              <a:srgbClr val="0F8140"/>
             </a:solidFill>
             <a:prstDash val="solid"/>
           </a:ln>
@@ -4049,7 +4105,7 @@
             <a:r>
               <a:rPr lang="en-US" sz="1150" b="1" dirty="0">
                 <a:solidFill>
-                  <a:srgbClr val="0E1F1A"/>
+                  <a:srgbClr val="0D1F14"/>
                 </a:solidFill>
                 <a:latin typeface="Arial" pitchFamily="34" charset="0"/>
                 <a:ea typeface="Arial" pitchFamily="34" charset="-122"/>
@@ -4104,7 +4160,7 @@
           </a:solidFill>
           <a:ln w="28575">
             <a:solidFill>
-              <a:srgbClr val="006A49"/>
+              <a:srgbClr val="0F8140"/>
             </a:solidFill>
             <a:prstDash val="solid"/>
           </a:ln>
@@ -4168,7 +4224,7 @@
             <a:r>
               <a:rPr lang="en-US" sz="1150" b="1" dirty="0">
                 <a:solidFill>
-                  <a:srgbClr val="0E1F1A"/>
+                  <a:srgbClr val="0D1F14"/>
                 </a:solidFill>
                 <a:latin typeface="Arial" pitchFamily="34" charset="0"/>
                 <a:ea typeface="Arial" pitchFamily="34" charset="-122"/>
@@ -4197,14 +4253,9 @@
             </a:avLst>
           </a:prstGeom>
           <a:solidFill>
-            <a:srgbClr val="006A49"/>
+            <a:srgbClr val="0F8140"/>
           </a:solidFill>
-          <a:ln w="9525">
-            <a:solidFill>
-              <a:srgbClr val="006A49"/>
-            </a:solidFill>
-            <a:prstDash val="solid"/>
-          </a:ln>
+          <a:ln/>
         </p:spPr>
       </p:sp>
       <p:sp>
@@ -4276,21 +4327,49 @@
             <a:r>
               <a:rPr lang="en-US" sz="800" b="1" spc="72" kern="0" dirty="0">
                 <a:solidFill>
-                  <a:srgbClr val="0E1F1A"/>
-                </a:solidFill>
-                <a:latin typeface="Arial" pitchFamily="34" charset="0"/>
-                <a:ea typeface="Arial" pitchFamily="34" charset="-122"/>
-                <a:cs typeface="Arial" pitchFamily="34" charset="-120"/>
-              </a:rPr>
-              <a:t>CAMP</a:t>
+                  <a:srgbClr val="0F8140"/>
+                </a:solidFill>
+                <a:latin typeface="Arial" pitchFamily="34" charset="0"/>
+                <a:ea typeface="Arial" pitchFamily="34" charset="-122"/>
+                <a:cs typeface="Arial" pitchFamily="34" charset="-120"/>
+              </a:rPr>
+              <a:t>C</a:t>
             </a:r>
             <a:pPr algn="l" indent="0" marL="0">
               <a:buNone/>
             </a:pPr>
             <a:r>
+              <a:rPr lang="en-US" sz="800" b="1" spc="72" kern="0" dirty="0">
+                <a:solidFill>
+                  <a:srgbClr val="A9C63C"/>
+                </a:solidFill>
+                <a:latin typeface="Arial" pitchFamily="34" charset="0"/>
+                <a:ea typeface="Arial" pitchFamily="34" charset="-122"/>
+                <a:cs typeface="Arial" pitchFamily="34" charset="-120"/>
+              </a:rPr>
+              <a:t>A</a:t>
+            </a:r>
+            <a:pPr algn="l" indent="0" marL="0">
+              <a:buNone/>
+            </a:pPr>
+            <a:r>
+              <a:rPr lang="en-US" sz="800" b="1" spc="72" kern="0" dirty="0">
+                <a:solidFill>
+                  <a:srgbClr val="0F8140"/>
+                </a:solidFill>
+                <a:latin typeface="Arial" pitchFamily="34" charset="0"/>
+                <a:ea typeface="Arial" pitchFamily="34" charset="-122"/>
+                <a:cs typeface="Arial" pitchFamily="34" charset="-120"/>
+              </a:rPr>
+              <a:t>MP</a:t>
+            </a:r>
+            <a:pPr algn="l" indent="0" marL="0">
+              <a:buNone/>
+            </a:pPr>
+            <a:r>
               <a:rPr lang="en-US" sz="800" spc="176" kern="0" dirty="0">
                 <a:solidFill>
-                  <a:srgbClr val="006A49"/>
+                  <a:srgbClr val="A9C63C"/>
                 </a:solidFill>
                 <a:latin typeface="Arial" pitchFamily="34" charset="0"/>
                 <a:ea typeface="Arial" pitchFamily="34" charset="-122"/>
@@ -4329,7 +4408,7 @@
             <a:r>
               <a:rPr lang="en-US" sz="800" b="1" spc="120" kern="0" dirty="0">
                 <a:solidFill>
-                  <a:srgbClr val="006A49"/>
+                  <a:srgbClr val="0F8140"/>
                 </a:solidFill>
                 <a:latin typeface="Arial" pitchFamily="34" charset="0"/>
                 <a:ea typeface="Arial" pitchFamily="34" charset="-122"/>
@@ -4355,7 +4434,7 @@
     <p:bg>
       <p:bgPr>
         <a:solidFill>
-          <a:srgbClr val="052C21"/>
+          <a:srgbClr val="06301A"/>
         </a:solidFill>
       </p:bgPr>
     </p:bg>
@@ -4468,7 +4547,7 @@
             <a:r>
               <a:rPr lang="en-US" sz="1150" dirty="0">
                 <a:solidFill>
-                  <a:srgbClr val="9FC4B7"/>
+                  <a:srgbClr val="A8C09B"/>
                 </a:solidFill>
                 <a:latin typeface="Arial" pitchFamily="34" charset="0"/>
                 <a:ea typeface="Arial" pitchFamily="34" charset="-122"/>
@@ -4485,7 +4564,7 @@
             <a:r>
               <a:rPr lang="en-US" sz="1150" b="1" dirty="0">
                 <a:solidFill>
-                  <a:srgbClr val="7FDCBB"/>
+                  <a:srgbClr val="A9C63C"/>
                 </a:solidFill>
                 <a:latin typeface="Arial" pitchFamily="34" charset="0"/>
                 <a:ea typeface="Arial" pitchFamily="34" charset="-122"/>
@@ -4502,7 +4581,7 @@
             <a:r>
               <a:rPr lang="en-US" sz="1150" dirty="0">
                 <a:solidFill>
-                  <a:srgbClr val="9FC4B7"/>
+                  <a:srgbClr val="A8C09B"/>
                 </a:solidFill>
                 <a:latin typeface="Arial" pitchFamily="34" charset="0"/>
                 <a:ea typeface="Arial" pitchFamily="34" charset="-122"/>
@@ -4531,11 +4610,11 @@
             </a:avLst>
           </a:prstGeom>
           <a:solidFill>
-            <a:srgbClr val="0A3A2C"/>
+            <a:srgbClr val="0B4526"/>
           </a:solidFill>
           <a:ln w="9525">
             <a:solidFill>
-              <a:srgbClr val="16513D"/>
+              <a:srgbClr val="1A5E34"/>
             </a:solidFill>
             <a:prstDash val="solid"/>
           </a:ln>
@@ -4556,11 +4635,11 @@
             <a:avLst/>
           </a:prstGeom>
           <a:solidFill>
-            <a:srgbClr val="0A3A2C"/>
+            <a:srgbClr val="0B4526"/>
           </a:solidFill>
           <a:ln w="11430">
             <a:solidFill>
-              <a:srgbClr val="7FDCBB"/>
+              <a:srgbClr val="A9C63C"/>
             </a:solidFill>
             <a:prstDash val="solid"/>
           </a:ln>
@@ -4662,7 +4741,7 @@
             <a:r>
               <a:rPr lang="en-US" sz="1000" dirty="0">
                 <a:solidFill>
-                  <a:srgbClr val="9FC4B7"/>
+                  <a:srgbClr val="A8C09B"/>
                 </a:solidFill>
                 <a:latin typeface="Arial" pitchFamily="34" charset="0"/>
                 <a:ea typeface="Arial" pitchFamily="34" charset="-122"/>
@@ -4691,11 +4770,11 @@
             </a:avLst>
           </a:prstGeom>
           <a:solidFill>
-            <a:srgbClr val="0A3A2C"/>
+            <a:srgbClr val="0B4526"/>
           </a:solidFill>
           <a:ln w="9525">
             <a:solidFill>
-              <a:srgbClr val="16513D"/>
+              <a:srgbClr val="1A5E34"/>
             </a:solidFill>
             <a:prstDash val="solid"/>
           </a:ln>
@@ -4716,11 +4795,11 @@
             <a:avLst/>
           </a:prstGeom>
           <a:solidFill>
-            <a:srgbClr val="0A3A2C"/>
+            <a:srgbClr val="0B4526"/>
           </a:solidFill>
           <a:ln w="11430">
             <a:solidFill>
-              <a:srgbClr val="7FDCBB"/>
+              <a:srgbClr val="A9C63C"/>
             </a:solidFill>
             <a:prstDash val="solid"/>
           </a:ln>
@@ -4822,7 +4901,7 @@
             <a:r>
               <a:rPr lang="en-US" sz="1000" dirty="0">
                 <a:solidFill>
-                  <a:srgbClr val="9FC4B7"/>
+                  <a:srgbClr val="A8C09B"/>
                 </a:solidFill>
                 <a:latin typeface="Arial" pitchFamily="34" charset="0"/>
                 <a:ea typeface="Arial" pitchFamily="34" charset="-122"/>
@@ -4851,11 +4930,11 @@
             </a:avLst>
           </a:prstGeom>
           <a:solidFill>
-            <a:srgbClr val="0A3A2C"/>
+            <a:srgbClr val="0B4526"/>
           </a:solidFill>
           <a:ln w="9525">
             <a:solidFill>
-              <a:srgbClr val="16513D"/>
+              <a:srgbClr val="1A5E34"/>
             </a:solidFill>
             <a:prstDash val="solid"/>
           </a:ln>
@@ -4876,11 +4955,11 @@
             <a:avLst/>
           </a:prstGeom>
           <a:solidFill>
-            <a:srgbClr val="0A3A2C"/>
+            <a:srgbClr val="0B4526"/>
           </a:solidFill>
           <a:ln w="11430">
             <a:solidFill>
-              <a:srgbClr val="7FDCBB"/>
+              <a:srgbClr val="A9C63C"/>
             </a:solidFill>
             <a:prstDash val="solid"/>
           </a:ln>
@@ -4982,7 +5061,7 @@
             <a:r>
               <a:rPr lang="en-US" sz="1000" dirty="0">
                 <a:solidFill>
-                  <a:srgbClr val="9FC4B7"/>
+                  <a:srgbClr val="A8C09B"/>
                 </a:solidFill>
                 <a:latin typeface="Arial" pitchFamily="34" charset="0"/>
                 <a:ea typeface="Arial" pitchFamily="34" charset="-122"/>
@@ -5011,7 +5090,7 @@
             </a:avLst>
           </a:prstGeom>
           <a:solidFill>
-            <a:srgbClr val="7FDCBB"/>
+            <a:srgbClr val="A9C63C"/>
           </a:solidFill>
           <a:ln/>
         </p:spPr>
@@ -5046,7 +5125,7 @@
             <a:r>
               <a:rPr lang="en-US" sz="1050" b="1" dirty="0">
                 <a:solidFill>
-                  <a:srgbClr val="052C21"/>
+                  <a:srgbClr val="06301A"/>
                 </a:solidFill>
                 <a:latin typeface="Arial" pitchFamily="34" charset="0"/>
                 <a:ea typeface="Arial" pitchFamily="34" charset="-122"/>
@@ -5091,15 +5170,43 @@
                 <a:ea typeface="Arial" pitchFamily="34" charset="-122"/>
                 <a:cs typeface="Arial" pitchFamily="34" charset="-120"/>
               </a:rPr>
-              <a:t>CAMP</a:t>
+              <a:t>C</a:t>
             </a:r>
             <a:pPr algn="l" indent="0" marL="0">
               <a:buNone/>
             </a:pPr>
             <a:r>
+              <a:rPr lang="en-US" sz="800" b="1" spc="72" kern="0" dirty="0">
+                <a:solidFill>
+                  <a:srgbClr val="A9C63C"/>
+                </a:solidFill>
+                <a:latin typeface="Arial" pitchFamily="34" charset="0"/>
+                <a:ea typeface="Arial" pitchFamily="34" charset="-122"/>
+                <a:cs typeface="Arial" pitchFamily="34" charset="-120"/>
+              </a:rPr>
+              <a:t>A</a:t>
+            </a:r>
+            <a:pPr algn="l" indent="0" marL="0">
+              <a:buNone/>
+            </a:pPr>
+            <a:r>
+              <a:rPr lang="en-US" sz="800" b="1" spc="72" kern="0" dirty="0">
+                <a:solidFill>
+                  <a:srgbClr val="FFFFFF"/>
+                </a:solidFill>
+                <a:latin typeface="Arial" pitchFamily="34" charset="0"/>
+                <a:ea typeface="Arial" pitchFamily="34" charset="-122"/>
+                <a:cs typeface="Arial" pitchFamily="34" charset="-120"/>
+              </a:rPr>
+              <a:t>MP</a:t>
+            </a:r>
+            <a:pPr algn="l" indent="0" marL="0">
+              <a:buNone/>
+            </a:pPr>
+            <a:r>
               <a:rPr lang="en-US" sz="800" spc="176" kern="0" dirty="0">
                 <a:solidFill>
-                  <a:srgbClr val="7FDCBB"/>
+                  <a:srgbClr val="A9C63C"/>
                 </a:solidFill>
                 <a:latin typeface="Arial" pitchFamily="34" charset="0"/>
                 <a:ea typeface="Arial" pitchFamily="34" charset="-122"/>
@@ -5138,7 +5245,7 @@
             <a:r>
               <a:rPr lang="en-US" sz="800" b="1" spc="120" kern="0" dirty="0">
                 <a:solidFill>
-                  <a:srgbClr val="7FDCBB"/>
+                  <a:srgbClr val="A9C63C"/>
                 </a:solidFill>
                 <a:latin typeface="Arial" pitchFamily="34" charset="0"/>
                 <a:ea typeface="Arial" pitchFamily="34" charset="-122"/>
@@ -5212,7 +5319,7 @@
             <a:r>
               <a:rPr lang="en-US" sz="2700" b="1" spc="-40" kern="0" dirty="0">
                 <a:solidFill>
-                  <a:srgbClr val="0E1F1A"/>
+                  <a:srgbClr val="0D1F14"/>
                 </a:solidFill>
                 <a:latin typeface="Arial" pitchFamily="34" charset="0"/>
                 <a:ea typeface="Arial" pitchFamily="34" charset="-122"/>
@@ -5241,11 +5348,11 @@
             </a:avLst>
           </a:prstGeom>
           <a:solidFill>
-            <a:srgbClr val="F3F7F5"/>
+            <a:srgbClr val="F4F7F2"/>
           </a:solidFill>
           <a:ln w="9525">
             <a:solidFill>
-              <a:srgbClr val="DDE7E3"/>
+              <a:srgbClr val="DEE6DE"/>
             </a:solidFill>
             <a:prstDash val="solid"/>
           </a:ln>
@@ -5281,7 +5388,7 @@
             <a:r>
               <a:rPr lang="en-US" sz="1300" b="1" dirty="0">
                 <a:solidFill>
-                  <a:srgbClr val="56645F"/>
+                  <a:srgbClr val="555F57"/>
                 </a:solidFill>
                 <a:latin typeface="Arial" pitchFamily="34" charset="0"/>
                 <a:ea typeface="Arial" pitchFamily="34" charset="-122"/>
@@ -5323,7 +5430,7 @@
             <a:r>
               <a:rPr lang="en-US" sz="1100" dirty="0">
                 <a:solidFill>
-                  <a:srgbClr val="56645F"/>
+                  <a:srgbClr val="555F57"/>
                 </a:solidFill>
                 <a:latin typeface="Arial" pitchFamily="34" charset="0"/>
                 <a:ea typeface="Arial" pitchFamily="34" charset="-122"/>
@@ -5340,7 +5447,7 @@
             <a:r>
               <a:rPr lang="en-US" sz="1100" b="1" dirty="0">
                 <a:solidFill>
-                  <a:srgbClr val="0E1F1A"/>
+                  <a:srgbClr val="0D1F14"/>
                 </a:solidFill>
                 <a:latin typeface="Arial" pitchFamily="34" charset="0"/>
                 <a:ea typeface="Arial" pitchFamily="34" charset="-122"/>
@@ -5357,7 +5464,7 @@
             <a:r>
               <a:rPr lang="en-US" sz="1100" dirty="0">
                 <a:solidFill>
-                  <a:srgbClr val="56645F"/>
+                  <a:srgbClr val="555F57"/>
                 </a:solidFill>
                 <a:latin typeface="Arial" pitchFamily="34" charset="0"/>
                 <a:ea typeface="Arial" pitchFamily="34" charset="-122"/>
@@ -5386,11 +5493,11 @@
             </a:avLst>
           </a:prstGeom>
           <a:solidFill>
-            <a:srgbClr val="EDF7F3"/>
+            <a:srgbClr val="EEF5E4"/>
           </a:solidFill>
           <a:ln w="9525">
             <a:solidFill>
-              <a:srgbClr val="CDE8DE"/>
+              <a:srgbClr val="CFE2B8"/>
             </a:solidFill>
             <a:prstDash val="solid"/>
           </a:ln>
@@ -5426,7 +5533,7 @@
             <a:r>
               <a:rPr lang="en-US" sz="1300" b="1" dirty="0">
                 <a:solidFill>
-                  <a:srgbClr val="006A49"/>
+                  <a:srgbClr val="0F8140"/>
                 </a:solidFill>
                 <a:latin typeface="Arial" pitchFamily="34" charset="0"/>
                 <a:ea typeface="Arial" pitchFamily="34" charset="-122"/>
@@ -5468,7 +5575,7 @@
             <a:r>
               <a:rPr lang="en-US" sz="1100" dirty="0">
                 <a:solidFill>
-                  <a:srgbClr val="3F5B51"/>
+                  <a:srgbClr val="44543F"/>
                 </a:solidFill>
                 <a:latin typeface="Arial" pitchFamily="34" charset="0"/>
                 <a:ea typeface="Arial" pitchFamily="34" charset="-122"/>
@@ -5485,7 +5592,7 @@
             <a:r>
               <a:rPr lang="en-US" sz="1100" b="1" dirty="0">
                 <a:solidFill>
-                  <a:srgbClr val="006A49"/>
+                  <a:srgbClr val="0F8140"/>
                 </a:solidFill>
                 <a:latin typeface="Arial" pitchFamily="34" charset="0"/>
                 <a:ea typeface="Arial" pitchFamily="34" charset="-122"/>
@@ -5502,7 +5609,7 @@
             <a:r>
               <a:rPr lang="en-US" sz="1100" dirty="0">
                 <a:solidFill>
-                  <a:srgbClr val="3F5B51"/>
+                  <a:srgbClr val="44543F"/>
                 </a:solidFill>
                 <a:latin typeface="Arial" pitchFamily="34" charset="0"/>
                 <a:ea typeface="Arial" pitchFamily="34" charset="-122"/>
@@ -5531,14 +5638,9 @@
             </a:avLst>
           </a:prstGeom>
           <a:solidFill>
-            <a:srgbClr val="006A49"/>
+            <a:srgbClr val="0F8140"/>
           </a:solidFill>
-          <a:ln w="9525">
-            <a:solidFill>
-              <a:srgbClr val="006A49"/>
-            </a:solidFill>
-            <a:prstDash val="solid"/>
-          </a:ln>
+          <a:ln/>
         </p:spPr>
       </p:sp>
       <p:sp>
@@ -5610,21 +5712,49 @@
             <a:r>
               <a:rPr lang="en-US" sz="800" b="1" spc="72" kern="0" dirty="0">
                 <a:solidFill>
-                  <a:srgbClr val="0E1F1A"/>
-                </a:solidFill>
-                <a:latin typeface="Arial" pitchFamily="34" charset="0"/>
-                <a:ea typeface="Arial" pitchFamily="34" charset="-122"/>
-                <a:cs typeface="Arial" pitchFamily="34" charset="-120"/>
-              </a:rPr>
-              <a:t>CAMP</a:t>
+                  <a:srgbClr val="0F8140"/>
+                </a:solidFill>
+                <a:latin typeface="Arial" pitchFamily="34" charset="0"/>
+                <a:ea typeface="Arial" pitchFamily="34" charset="-122"/>
+                <a:cs typeface="Arial" pitchFamily="34" charset="-120"/>
+              </a:rPr>
+              <a:t>C</a:t>
             </a:r>
             <a:pPr algn="l" indent="0" marL="0">
               <a:buNone/>
             </a:pPr>
             <a:r>
+              <a:rPr lang="en-US" sz="800" b="1" spc="72" kern="0" dirty="0">
+                <a:solidFill>
+                  <a:srgbClr val="A9C63C"/>
+                </a:solidFill>
+                <a:latin typeface="Arial" pitchFamily="34" charset="0"/>
+                <a:ea typeface="Arial" pitchFamily="34" charset="-122"/>
+                <a:cs typeface="Arial" pitchFamily="34" charset="-120"/>
+              </a:rPr>
+              <a:t>A</a:t>
+            </a:r>
+            <a:pPr algn="l" indent="0" marL="0">
+              <a:buNone/>
+            </a:pPr>
+            <a:r>
+              <a:rPr lang="en-US" sz="800" b="1" spc="72" kern="0" dirty="0">
+                <a:solidFill>
+                  <a:srgbClr val="0F8140"/>
+                </a:solidFill>
+                <a:latin typeface="Arial" pitchFamily="34" charset="0"/>
+                <a:ea typeface="Arial" pitchFamily="34" charset="-122"/>
+                <a:cs typeface="Arial" pitchFamily="34" charset="-120"/>
+              </a:rPr>
+              <a:t>MP</a:t>
+            </a:r>
+            <a:pPr algn="l" indent="0" marL="0">
+              <a:buNone/>
+            </a:pPr>
+            <a:r>
               <a:rPr lang="en-US" sz="800" spc="176" kern="0" dirty="0">
                 <a:solidFill>
-                  <a:srgbClr val="006A49"/>
+                  <a:srgbClr val="A9C63C"/>
                 </a:solidFill>
                 <a:latin typeface="Arial" pitchFamily="34" charset="0"/>
                 <a:ea typeface="Arial" pitchFamily="34" charset="-122"/>
@@ -5663,7 +5793,7 @@
             <a:r>
               <a:rPr lang="en-US" sz="800" b="1" spc="120" kern="0" dirty="0">
                 <a:solidFill>
-                  <a:srgbClr val="006A49"/>
+                  <a:srgbClr val="0F8140"/>
                 </a:solidFill>
                 <a:latin typeface="Arial" pitchFamily="34" charset="0"/>
                 <a:ea typeface="Arial" pitchFamily="34" charset="-122"/>
@@ -5760,7 +5890,7 @@
             <a:r>
               <a:rPr lang="en-US" sz="2500" b="1" spc="-40" kern="0" dirty="0">
                 <a:solidFill>
-                  <a:srgbClr val="0E1F1A"/>
+                  <a:srgbClr val="0D1F14"/>
                 </a:solidFill>
                 <a:latin typeface="Arial" pitchFamily="34" charset="0"/>
                 <a:ea typeface="Arial" pitchFamily="34" charset="-122"/>
@@ -5793,7 +5923,7 @@
           </a:solidFill>
           <a:ln w="9525">
             <a:solidFill>
-              <a:srgbClr val="DDE7E3"/>
+              <a:srgbClr val="DEE6DE"/>
             </a:solidFill>
             <a:prstDash val="solid"/>
           </a:ln>
@@ -5836,7 +5966,7 @@
             <a:r>
               <a:rPr lang="en-US" sz="1250" b="1" dirty="0">
                 <a:solidFill>
-                  <a:srgbClr val="0E1F1A"/>
+                  <a:srgbClr val="0D1F14"/>
                 </a:solidFill>
                 <a:latin typeface="Arial" pitchFamily="34" charset="0"/>
                 <a:ea typeface="Arial" pitchFamily="34" charset="-122"/>
@@ -5878,7 +6008,7 @@
             <a:r>
               <a:rPr lang="en-US" sz="1000" dirty="0">
                 <a:solidFill>
-                  <a:srgbClr val="56645F"/>
+                  <a:srgbClr val="555F57"/>
                 </a:solidFill>
                 <a:latin typeface="Arial" pitchFamily="34" charset="0"/>
                 <a:ea typeface="Arial" pitchFamily="34" charset="-122"/>
@@ -5911,7 +6041,7 @@
           </a:solidFill>
           <a:ln w="9525">
             <a:solidFill>
-              <a:srgbClr val="DDE7E3"/>
+              <a:srgbClr val="DEE6DE"/>
             </a:solidFill>
             <a:prstDash val="solid"/>
           </a:ln>
@@ -5954,7 +6084,7 @@
             <a:r>
               <a:rPr lang="en-US" sz="1250" b="1" dirty="0">
                 <a:solidFill>
-                  <a:srgbClr val="0E1F1A"/>
+                  <a:srgbClr val="0D1F14"/>
                 </a:solidFill>
                 <a:latin typeface="Arial" pitchFamily="34" charset="0"/>
                 <a:ea typeface="Arial" pitchFamily="34" charset="-122"/>
@@ -5996,7 +6126,7 @@
             <a:r>
               <a:rPr lang="en-US" sz="1000" dirty="0">
                 <a:solidFill>
-                  <a:srgbClr val="56645F"/>
+                  <a:srgbClr val="555F57"/>
                 </a:solidFill>
                 <a:latin typeface="Arial" pitchFamily="34" charset="0"/>
                 <a:ea typeface="Arial" pitchFamily="34" charset="-122"/>
@@ -6025,11 +6155,11 @@
             </a:avLst>
           </a:prstGeom>
           <a:solidFill>
-            <a:srgbClr val="EDF7F3"/>
+            <a:srgbClr val="EEF5E4"/>
           </a:solidFill>
           <a:ln w="9525">
             <a:solidFill>
-              <a:srgbClr val="CDE8DE"/>
+              <a:srgbClr val="CFE2B8"/>
             </a:solidFill>
             <a:prstDash val="solid"/>
           </a:ln>
@@ -6065,7 +6195,7 @@
             <a:r>
               <a:rPr lang="en-US" sz="1250" b="1" dirty="0">
                 <a:solidFill>
-                  <a:srgbClr val="006A49"/>
+                  <a:srgbClr val="0F8140"/>
                 </a:solidFill>
                 <a:latin typeface="Arial" pitchFamily="34" charset="0"/>
                 <a:ea typeface="Arial" pitchFamily="34" charset="-122"/>
@@ -6107,7 +6237,7 @@
             <a:r>
               <a:rPr lang="en-US" sz="1000" dirty="0">
                 <a:solidFill>
-                  <a:srgbClr val="3F5B51"/>
+                  <a:srgbClr val="44543F"/>
                 </a:solidFill>
                 <a:latin typeface="Arial" pitchFamily="34" charset="0"/>
                 <a:ea typeface="Arial" pitchFamily="34" charset="-122"/>
@@ -6146,21 +6276,49 @@
             <a:r>
               <a:rPr lang="en-US" sz="800" b="1" spc="72" kern="0" dirty="0">
                 <a:solidFill>
-                  <a:srgbClr val="0E1F1A"/>
-                </a:solidFill>
-                <a:latin typeface="Arial" pitchFamily="34" charset="0"/>
-                <a:ea typeface="Arial" pitchFamily="34" charset="-122"/>
-                <a:cs typeface="Arial" pitchFamily="34" charset="-120"/>
-              </a:rPr>
-              <a:t>CAMP</a:t>
+                  <a:srgbClr val="0F8140"/>
+                </a:solidFill>
+                <a:latin typeface="Arial" pitchFamily="34" charset="0"/>
+                <a:ea typeface="Arial" pitchFamily="34" charset="-122"/>
+                <a:cs typeface="Arial" pitchFamily="34" charset="-120"/>
+              </a:rPr>
+              <a:t>C</a:t>
             </a:r>
             <a:pPr algn="l" indent="0" marL="0">
               <a:buNone/>
             </a:pPr>
             <a:r>
+              <a:rPr lang="en-US" sz="800" b="1" spc="72" kern="0" dirty="0">
+                <a:solidFill>
+                  <a:srgbClr val="A9C63C"/>
+                </a:solidFill>
+                <a:latin typeface="Arial" pitchFamily="34" charset="0"/>
+                <a:ea typeface="Arial" pitchFamily="34" charset="-122"/>
+                <a:cs typeface="Arial" pitchFamily="34" charset="-120"/>
+              </a:rPr>
+              <a:t>A</a:t>
+            </a:r>
+            <a:pPr algn="l" indent="0" marL="0">
+              <a:buNone/>
+            </a:pPr>
+            <a:r>
+              <a:rPr lang="en-US" sz="800" b="1" spc="72" kern="0" dirty="0">
+                <a:solidFill>
+                  <a:srgbClr val="0F8140"/>
+                </a:solidFill>
+                <a:latin typeface="Arial" pitchFamily="34" charset="0"/>
+                <a:ea typeface="Arial" pitchFamily="34" charset="-122"/>
+                <a:cs typeface="Arial" pitchFamily="34" charset="-120"/>
+              </a:rPr>
+              <a:t>MP</a:t>
+            </a:r>
+            <a:pPr algn="l" indent="0" marL="0">
+              <a:buNone/>
+            </a:pPr>
+            <a:r>
               <a:rPr lang="en-US" sz="800" spc="176" kern="0" dirty="0">
                 <a:solidFill>
-                  <a:srgbClr val="006A49"/>
+                  <a:srgbClr val="A9C63C"/>
                 </a:solidFill>
                 <a:latin typeface="Arial" pitchFamily="34" charset="0"/>
                 <a:ea typeface="Arial" pitchFamily="34" charset="-122"/>
@@ -6199,7 +6357,7 @@
             <a:r>
               <a:rPr lang="en-US" sz="800" b="1" spc="120" kern="0" dirty="0">
                 <a:solidFill>
-                  <a:srgbClr val="7FDCBB"/>
+                  <a:srgbClr val="A9C63C"/>
                 </a:solidFill>
                 <a:latin typeface="Arial" pitchFamily="34" charset="0"/>
                 <a:ea typeface="Arial" pitchFamily="34" charset="-122"/>
@@ -6273,7 +6431,7 @@
             <a:r>
               <a:rPr lang="en-US" sz="2700" b="1" spc="-40" kern="0" dirty="0">
                 <a:solidFill>
-                  <a:srgbClr val="0E1F1A"/>
+                  <a:srgbClr val="0D1F14"/>
                 </a:solidFill>
                 <a:latin typeface="Arial" pitchFamily="34" charset="0"/>
                 <a:ea typeface="Arial" pitchFamily="34" charset="-122"/>
@@ -6302,7 +6460,7 @@
             </a:avLst>
           </a:prstGeom>
           <a:solidFill>
-            <a:srgbClr val="006A49"/>
+            <a:srgbClr val="0F8140"/>
           </a:solidFill>
           <a:ln/>
         </p:spPr>
@@ -6432,7 +6590,7 @@
             <a:r>
               <a:rPr lang="en-US" sz="1150" b="1" dirty="0">
                 <a:solidFill>
-                  <a:srgbClr val="0E1F1A"/>
+                  <a:srgbClr val="0D1F14"/>
                 </a:solidFill>
                 <a:latin typeface="Arial" pitchFamily="34" charset="0"/>
                 <a:ea typeface="Arial" pitchFamily="34" charset="-122"/>
@@ -6474,7 +6632,7 @@
             <a:r>
               <a:rPr lang="en-US" sz="1050" dirty="0">
                 <a:solidFill>
-                  <a:srgbClr val="56645F"/>
+                  <a:srgbClr val="555F57"/>
                 </a:solidFill>
                 <a:latin typeface="Arial" pitchFamily="34" charset="0"/>
                 <a:ea typeface="Arial" pitchFamily="34" charset="-122"/>
@@ -6516,7 +6674,7 @@
             <a:r>
               <a:rPr lang="en-US" sz="1050" dirty="0">
                 <a:solidFill>
-                  <a:srgbClr val="56645F"/>
+                  <a:srgbClr val="555F57"/>
                 </a:solidFill>
                 <a:latin typeface="Arial" pitchFamily="34" charset="0"/>
                 <a:ea typeface="Arial" pitchFamily="34" charset="-122"/>
@@ -6543,7 +6701,7 @@
             <a:avLst/>
           </a:prstGeom>
           <a:solidFill>
-            <a:srgbClr val="F3F7F5"/>
+            <a:srgbClr val="F4F7F2"/>
           </a:solidFill>
           <a:ln/>
         </p:spPr>
@@ -6563,7 +6721,7 @@
             <a:avLst/>
           </a:prstGeom>
           <a:solidFill>
-            <a:srgbClr val="DDE7E3"/>
+            <a:srgbClr val="DEE6DE"/>
           </a:solidFill>
           <a:ln/>
         </p:spPr>
@@ -6595,7 +6753,7 @@
             <a:r>
               <a:rPr lang="en-US" sz="1150" b="1" dirty="0">
                 <a:solidFill>
-                  <a:srgbClr val="0E1F1A"/>
+                  <a:srgbClr val="0D1F14"/>
                 </a:solidFill>
                 <a:latin typeface="Arial" pitchFamily="34" charset="0"/>
                 <a:ea typeface="Arial" pitchFamily="34" charset="-122"/>
@@ -6637,7 +6795,7 @@
             <a:r>
               <a:rPr lang="en-US" sz="1050" dirty="0">
                 <a:solidFill>
-                  <a:srgbClr val="56645F"/>
+                  <a:srgbClr val="555F57"/>
                 </a:solidFill>
                 <a:latin typeface="Arial" pitchFamily="34" charset="0"/>
                 <a:ea typeface="Arial" pitchFamily="34" charset="-122"/>
@@ -6679,7 +6837,7 @@
             <a:r>
               <a:rPr lang="en-US" sz="1050" dirty="0">
                 <a:solidFill>
-                  <a:srgbClr val="56645F"/>
+                  <a:srgbClr val="555F57"/>
                 </a:solidFill>
                 <a:latin typeface="Arial" pitchFamily="34" charset="0"/>
                 <a:ea typeface="Arial" pitchFamily="34" charset="-122"/>
@@ -6726,7 +6884,7 @@
             <a:avLst/>
           </a:prstGeom>
           <a:solidFill>
-            <a:srgbClr val="DDE7E3"/>
+            <a:srgbClr val="DEE6DE"/>
           </a:solidFill>
           <a:ln/>
         </p:spPr>
@@ -6758,7 +6916,7 @@
             <a:r>
               <a:rPr lang="en-US" sz="1150" b="1" dirty="0">
                 <a:solidFill>
-                  <a:srgbClr val="0E1F1A"/>
+                  <a:srgbClr val="0D1F14"/>
                 </a:solidFill>
                 <a:latin typeface="Arial" pitchFamily="34" charset="0"/>
                 <a:ea typeface="Arial" pitchFamily="34" charset="-122"/>
@@ -6800,7 +6958,7 @@
             <a:r>
               <a:rPr lang="en-US" sz="1050" dirty="0">
                 <a:solidFill>
-                  <a:srgbClr val="56645F"/>
+                  <a:srgbClr val="555F57"/>
                 </a:solidFill>
                 <a:latin typeface="Arial" pitchFamily="34" charset="0"/>
                 <a:ea typeface="Arial" pitchFamily="34" charset="-122"/>
@@ -6842,7 +7000,7 @@
             <a:r>
               <a:rPr lang="en-US" sz="1050" dirty="0">
                 <a:solidFill>
-                  <a:srgbClr val="56645F"/>
+                  <a:srgbClr val="555F57"/>
                 </a:solidFill>
                 <a:latin typeface="Arial" pitchFamily="34" charset="0"/>
                 <a:ea typeface="Arial" pitchFamily="34" charset="-122"/>
@@ -6869,7 +7027,7 @@
             <a:avLst/>
           </a:prstGeom>
           <a:solidFill>
-            <a:srgbClr val="DDE7E3"/>
+            <a:srgbClr val="DEE6DE"/>
           </a:solidFill>
           <a:ln/>
         </p:spPr>
@@ -6891,14 +7049,9 @@
             </a:avLst>
           </a:prstGeom>
           <a:solidFill>
-            <a:srgbClr val="006A49"/>
+            <a:srgbClr val="0F8140"/>
           </a:solidFill>
-          <a:ln w="9525">
-            <a:solidFill>
-              <a:srgbClr val="006A49"/>
-            </a:solidFill>
-            <a:prstDash val="solid"/>
-          </a:ln>
+          <a:ln/>
         </p:spPr>
       </p:sp>
       <p:sp>
@@ -6970,21 +7123,49 @@
             <a:r>
               <a:rPr lang="en-US" sz="800" b="1" spc="72" kern="0" dirty="0">
                 <a:solidFill>
-                  <a:srgbClr val="0E1F1A"/>
-                </a:solidFill>
-                <a:latin typeface="Arial" pitchFamily="34" charset="0"/>
-                <a:ea typeface="Arial" pitchFamily="34" charset="-122"/>
-                <a:cs typeface="Arial" pitchFamily="34" charset="-120"/>
-              </a:rPr>
-              <a:t>CAMP</a:t>
+                  <a:srgbClr val="0F8140"/>
+                </a:solidFill>
+                <a:latin typeface="Arial" pitchFamily="34" charset="0"/>
+                <a:ea typeface="Arial" pitchFamily="34" charset="-122"/>
+                <a:cs typeface="Arial" pitchFamily="34" charset="-120"/>
+              </a:rPr>
+              <a:t>C</a:t>
             </a:r>
             <a:pPr algn="l" indent="0" marL="0">
               <a:buNone/>
             </a:pPr>
             <a:r>
+              <a:rPr lang="en-US" sz="800" b="1" spc="72" kern="0" dirty="0">
+                <a:solidFill>
+                  <a:srgbClr val="A9C63C"/>
+                </a:solidFill>
+                <a:latin typeface="Arial" pitchFamily="34" charset="0"/>
+                <a:ea typeface="Arial" pitchFamily="34" charset="-122"/>
+                <a:cs typeface="Arial" pitchFamily="34" charset="-120"/>
+              </a:rPr>
+              <a:t>A</a:t>
+            </a:r>
+            <a:pPr algn="l" indent="0" marL="0">
+              <a:buNone/>
+            </a:pPr>
+            <a:r>
+              <a:rPr lang="en-US" sz="800" b="1" spc="72" kern="0" dirty="0">
+                <a:solidFill>
+                  <a:srgbClr val="0F8140"/>
+                </a:solidFill>
+                <a:latin typeface="Arial" pitchFamily="34" charset="0"/>
+                <a:ea typeface="Arial" pitchFamily="34" charset="-122"/>
+                <a:cs typeface="Arial" pitchFamily="34" charset="-120"/>
+              </a:rPr>
+              <a:t>MP</a:t>
+            </a:r>
+            <a:pPr algn="l" indent="0" marL="0">
+              <a:buNone/>
+            </a:pPr>
+            <a:r>
               <a:rPr lang="en-US" sz="800" spc="176" kern="0" dirty="0">
                 <a:solidFill>
-                  <a:srgbClr val="006A49"/>
+                  <a:srgbClr val="A9C63C"/>
                 </a:solidFill>
                 <a:latin typeface="Arial" pitchFamily="34" charset="0"/>
                 <a:ea typeface="Arial" pitchFamily="34" charset="-122"/>
@@ -7023,7 +7204,7 @@
             <a:r>
               <a:rPr lang="en-US" sz="800" b="1" spc="120" kern="0" dirty="0">
                 <a:solidFill>
-                  <a:srgbClr val="006A49"/>
+                  <a:srgbClr val="0F8140"/>
                 </a:solidFill>
                 <a:latin typeface="Arial" pitchFamily="34" charset="0"/>
                 <a:ea typeface="Arial" pitchFamily="34" charset="-122"/>
@@ -7097,7 +7278,7 @@
             <a:r>
               <a:rPr lang="en-US" sz="2700" b="1" spc="-40" kern="0" dirty="0">
                 <a:solidFill>
-                  <a:srgbClr val="0E1F1A"/>
+                  <a:srgbClr val="0D1F14"/>
                 </a:solidFill>
                 <a:latin typeface="Arial" pitchFamily="34" charset="0"/>
                 <a:ea typeface="Arial" pitchFamily="34" charset="-122"/>
@@ -7126,11 +7307,11 @@
             </a:avLst>
           </a:prstGeom>
           <a:solidFill>
-            <a:srgbClr val="F3F7F5"/>
+            <a:srgbClr val="F4F7F2"/>
           </a:solidFill>
           <a:ln w="9525">
             <a:solidFill>
-              <a:srgbClr val="DDE7E3"/>
+              <a:srgbClr val="DEE6DE"/>
             </a:solidFill>
             <a:prstDash val="solid"/>
           </a:ln>
@@ -7155,7 +7336,7 @@
           </a:solidFill>
           <a:ln w="28575">
             <a:solidFill>
-              <a:srgbClr val="006A49"/>
+              <a:srgbClr val="0F8140"/>
             </a:solidFill>
             <a:prstDash val="solid"/>
           </a:ln>
@@ -7222,7 +7403,7 @@
             <a:r>
               <a:rPr lang="en-US" sz="1100" b="1" dirty="0">
                 <a:solidFill>
-                  <a:srgbClr val="0E1F1A"/>
+                  <a:srgbClr val="0D1F14"/>
                 </a:solidFill>
                 <a:latin typeface="Arial" pitchFamily="34" charset="0"/>
                 <a:ea typeface="Arial" pitchFamily="34" charset="-122"/>
@@ -7277,7 +7458,7 @@
           </a:solidFill>
           <a:ln w="28575">
             <a:solidFill>
-              <a:srgbClr val="006A49"/>
+              <a:srgbClr val="0F8140"/>
             </a:solidFill>
             <a:prstDash val="solid"/>
           </a:ln>
@@ -7344,7 +7525,7 @@
             <a:r>
               <a:rPr lang="en-US" sz="1100" b="1" dirty="0">
                 <a:solidFill>
-                  <a:srgbClr val="0E1F1A"/>
+                  <a:srgbClr val="0D1F14"/>
                 </a:solidFill>
                 <a:latin typeface="Arial" pitchFamily="34" charset="0"/>
                 <a:ea typeface="Arial" pitchFamily="34" charset="-122"/>
@@ -7399,7 +7580,7 @@
           </a:solidFill>
           <a:ln w="28575">
             <a:solidFill>
-              <a:srgbClr val="006A49"/>
+              <a:srgbClr val="0F8140"/>
             </a:solidFill>
             <a:prstDash val="solid"/>
           </a:ln>
@@ -7466,7 +7647,7 @@
             <a:r>
               <a:rPr lang="en-US" sz="1100" b="1" dirty="0">
                 <a:solidFill>
-                  <a:srgbClr val="0E1F1A"/>
+                  <a:srgbClr val="0D1F14"/>
                 </a:solidFill>
                 <a:latin typeface="Arial" pitchFamily="34" charset="0"/>
                 <a:ea typeface="Arial" pitchFamily="34" charset="-122"/>
@@ -7508,7 +7689,7 @@
             <a:r>
               <a:rPr lang="en-US" sz="1300" b="1" dirty="0">
                 <a:solidFill>
-                  <a:srgbClr val="006A49"/>
+                  <a:srgbClr val="0F8140"/>
                 </a:solidFill>
                 <a:latin typeface="Arial" pitchFamily="34" charset="0"/>
                 <a:ea typeface="Arial" pitchFamily="34" charset="-122"/>
@@ -7550,7 +7731,7 @@
             <a:r>
               <a:rPr lang="en-US" sz="1050" dirty="0">
                 <a:solidFill>
-                  <a:srgbClr val="56645F"/>
+                  <a:srgbClr val="555F57"/>
                 </a:solidFill>
                 <a:latin typeface="Arial" pitchFamily="34" charset="0"/>
                 <a:ea typeface="Arial" pitchFamily="34" charset="-122"/>
@@ -7567,7 +7748,7 @@
             <a:r>
               <a:rPr lang="en-US" sz="1050" b="1" dirty="0">
                 <a:solidFill>
-                  <a:srgbClr val="0E1F1A"/>
+                  <a:srgbClr val="0D1F14"/>
                 </a:solidFill>
                 <a:latin typeface="Arial" pitchFamily="34" charset="0"/>
                 <a:ea typeface="Arial" pitchFamily="34" charset="-122"/>
@@ -7584,7 +7765,7 @@
             <a:r>
               <a:rPr lang="en-US" sz="1050" dirty="0">
                 <a:solidFill>
-                  <a:srgbClr val="56645F"/>
+                  <a:srgbClr val="555F57"/>
                 </a:solidFill>
                 <a:latin typeface="Arial" pitchFamily="34" charset="0"/>
                 <a:ea typeface="Arial" pitchFamily="34" charset="-122"/>
@@ -7611,7 +7792,7 @@
             <a:avLst/>
           </a:prstGeom>
           <a:solidFill>
-            <a:srgbClr val="DDE7E3"/>
+            <a:srgbClr val="DEE6DE"/>
           </a:solidFill>
           <a:ln/>
         </p:spPr>
@@ -7646,7 +7827,7 @@
             <a:r>
               <a:rPr lang="en-US" sz="1300" b="1" dirty="0">
                 <a:solidFill>
-                  <a:srgbClr val="006A49"/>
+                  <a:srgbClr val="0F8140"/>
                 </a:solidFill>
                 <a:latin typeface="Arial" pitchFamily="34" charset="0"/>
                 <a:ea typeface="Arial" pitchFamily="34" charset="-122"/>
@@ -7688,7 +7869,7 @@
             <a:r>
               <a:rPr lang="en-US" sz="1050" dirty="0">
                 <a:solidFill>
-                  <a:srgbClr val="56645F"/>
+                  <a:srgbClr val="555F57"/>
                 </a:solidFill>
                 <a:latin typeface="Arial" pitchFamily="34" charset="0"/>
                 <a:ea typeface="Arial" pitchFamily="34" charset="-122"/>
@@ -7705,7 +7886,7 @@
             <a:r>
               <a:rPr lang="en-US" sz="1050" b="1" dirty="0">
                 <a:solidFill>
-                  <a:srgbClr val="0E1F1A"/>
+                  <a:srgbClr val="0D1F14"/>
                 </a:solidFill>
                 <a:latin typeface="Arial" pitchFamily="34" charset="0"/>
                 <a:ea typeface="Arial" pitchFamily="34" charset="-122"/>
@@ -7722,7 +7903,7 @@
             <a:r>
               <a:rPr lang="en-US" sz="1050" dirty="0">
                 <a:solidFill>
-                  <a:srgbClr val="56645F"/>
+                  <a:srgbClr val="555F57"/>
                 </a:solidFill>
                 <a:latin typeface="Arial" pitchFamily="34" charset="0"/>
                 <a:ea typeface="Arial" pitchFamily="34" charset="-122"/>
@@ -7761,21 +7942,49 @@
             <a:r>
               <a:rPr lang="en-US" sz="800" b="1" spc="72" kern="0" dirty="0">
                 <a:solidFill>
-                  <a:srgbClr val="0E1F1A"/>
-                </a:solidFill>
-                <a:latin typeface="Arial" pitchFamily="34" charset="0"/>
-                <a:ea typeface="Arial" pitchFamily="34" charset="-122"/>
-                <a:cs typeface="Arial" pitchFamily="34" charset="-120"/>
-              </a:rPr>
-              <a:t>CAMP</a:t>
+                  <a:srgbClr val="0F8140"/>
+                </a:solidFill>
+                <a:latin typeface="Arial" pitchFamily="34" charset="0"/>
+                <a:ea typeface="Arial" pitchFamily="34" charset="-122"/>
+                <a:cs typeface="Arial" pitchFamily="34" charset="-120"/>
+              </a:rPr>
+              <a:t>C</a:t>
             </a:r>
             <a:pPr algn="l" indent="0" marL="0">
               <a:buNone/>
             </a:pPr>
             <a:r>
+              <a:rPr lang="en-US" sz="800" b="1" spc="72" kern="0" dirty="0">
+                <a:solidFill>
+                  <a:srgbClr val="A9C63C"/>
+                </a:solidFill>
+                <a:latin typeface="Arial" pitchFamily="34" charset="0"/>
+                <a:ea typeface="Arial" pitchFamily="34" charset="-122"/>
+                <a:cs typeface="Arial" pitchFamily="34" charset="-120"/>
+              </a:rPr>
+              <a:t>A</a:t>
+            </a:r>
+            <a:pPr algn="l" indent="0" marL="0">
+              <a:buNone/>
+            </a:pPr>
+            <a:r>
+              <a:rPr lang="en-US" sz="800" b="1" spc="72" kern="0" dirty="0">
+                <a:solidFill>
+                  <a:srgbClr val="0F8140"/>
+                </a:solidFill>
+                <a:latin typeface="Arial" pitchFamily="34" charset="0"/>
+                <a:ea typeface="Arial" pitchFamily="34" charset="-122"/>
+                <a:cs typeface="Arial" pitchFamily="34" charset="-120"/>
+              </a:rPr>
+              <a:t>MP</a:t>
+            </a:r>
+            <a:pPr algn="l" indent="0" marL="0">
+              <a:buNone/>
+            </a:pPr>
+            <a:r>
               <a:rPr lang="en-US" sz="800" spc="176" kern="0" dirty="0">
                 <a:solidFill>
-                  <a:srgbClr val="006A49"/>
+                  <a:srgbClr val="A9C63C"/>
                 </a:solidFill>
                 <a:latin typeface="Arial" pitchFamily="34" charset="0"/>
                 <a:ea typeface="Arial" pitchFamily="34" charset="-122"/>
@@ -7814,7 +8023,7 @@
             <a:r>
               <a:rPr lang="en-US" sz="800" b="1" spc="120" kern="0" dirty="0">
                 <a:solidFill>
-                  <a:srgbClr val="006A49"/>
+                  <a:srgbClr val="0F8140"/>
                 </a:solidFill>
                 <a:latin typeface="Arial" pitchFamily="34" charset="0"/>
                 <a:ea typeface="Arial" pitchFamily="34" charset="-122"/>
@@ -7888,7 +8097,7 @@
             <a:r>
               <a:rPr lang="en-US" sz="2700" b="1" spc="-40" kern="0" dirty="0">
                 <a:solidFill>
-                  <a:srgbClr val="0E1F1A"/>
+                  <a:srgbClr val="0D1F14"/>
                 </a:solidFill>
                 <a:latin typeface="Arial" pitchFamily="34" charset="0"/>
                 <a:ea typeface="Arial" pitchFamily="34" charset="-122"/>
@@ -7917,11 +8126,11 @@
             </a:avLst>
           </a:prstGeom>
           <a:solidFill>
-            <a:srgbClr val="F3F7F5"/>
+            <a:srgbClr val="F4F7F2"/>
           </a:solidFill>
           <a:ln w="9525">
             <a:solidFill>
-              <a:srgbClr val="DDE7E3"/>
+              <a:srgbClr val="DEE6DE"/>
             </a:solidFill>
             <a:prstDash val="solid"/>
           </a:ln>
@@ -7981,7 +8190,7 @@
             <a:r>
               <a:rPr lang="en-US" sz="1300" b="1" dirty="0">
                 <a:solidFill>
-                  <a:srgbClr val="006A49"/>
+                  <a:srgbClr val="0F8140"/>
                 </a:solidFill>
                 <a:latin typeface="Arial" pitchFamily="34" charset="0"/>
                 <a:ea typeface="Arial" pitchFamily="34" charset="-122"/>
@@ -8023,7 +8232,7 @@
             <a:r>
               <a:rPr lang="en-US" sz="1100" dirty="0">
                 <a:solidFill>
-                  <a:srgbClr val="56645F"/>
+                  <a:srgbClr val="555F57"/>
                 </a:solidFill>
                 <a:latin typeface="Arial" pitchFamily="34" charset="0"/>
                 <a:ea typeface="Arial" pitchFamily="34" charset="-122"/>
@@ -8050,7 +8259,7 @@
             <a:avLst/>
           </a:prstGeom>
           <a:solidFill>
-            <a:srgbClr val="DDE7E3"/>
+            <a:srgbClr val="DEE6DE"/>
           </a:solidFill>
           <a:ln/>
         </p:spPr>
@@ -8085,7 +8294,7 @@
             <a:r>
               <a:rPr lang="en-US" sz="1300" b="1" dirty="0">
                 <a:solidFill>
-                  <a:srgbClr val="006A49"/>
+                  <a:srgbClr val="0F8140"/>
                 </a:solidFill>
                 <a:latin typeface="Arial" pitchFamily="34" charset="0"/>
                 <a:ea typeface="Arial" pitchFamily="34" charset="-122"/>
@@ -8112,7 +8321,7 @@
             <a:avLst/>
           </a:prstGeom>
           <a:solidFill>
-            <a:srgbClr val="006A49"/>
+            <a:srgbClr val="0F8140"/>
           </a:solidFill>
           <a:ln/>
         </p:spPr>
@@ -8147,7 +8356,7 @@
             <a:r>
               <a:rPr lang="en-US" sz="1100" b="1" dirty="0">
                 <a:solidFill>
-                  <a:srgbClr val="0E1F1A"/>
+                  <a:srgbClr val="0D1F14"/>
                 </a:solidFill>
                 <a:latin typeface="Arial" pitchFamily="34" charset="0"/>
                 <a:ea typeface="Arial" pitchFamily="34" charset="-122"/>
@@ -8164,7 +8373,7 @@
             <a:r>
               <a:rPr lang="en-US" sz="1100" dirty="0">
                 <a:solidFill>
-                  <a:srgbClr val="56645F"/>
+                  <a:srgbClr val="555F57"/>
                 </a:solidFill>
                 <a:latin typeface="Arial" pitchFamily="34" charset="0"/>
                 <a:ea typeface="Arial" pitchFamily="34" charset="-122"/>
@@ -8191,7 +8400,7 @@
             <a:avLst/>
           </a:prstGeom>
           <a:solidFill>
-            <a:srgbClr val="006A49"/>
+            <a:srgbClr val="0F8140"/>
           </a:solidFill>
           <a:ln/>
         </p:spPr>
@@ -8226,7 +8435,7 @@
             <a:r>
               <a:rPr lang="en-US" sz="1100" b="1" dirty="0">
                 <a:solidFill>
-                  <a:srgbClr val="0E1F1A"/>
+                  <a:srgbClr val="0D1F14"/>
                 </a:solidFill>
                 <a:latin typeface="Arial" pitchFamily="34" charset="0"/>
                 <a:ea typeface="Arial" pitchFamily="34" charset="-122"/>
@@ -8243,7 +8452,7 @@
             <a:r>
               <a:rPr lang="en-US" sz="1100" dirty="0">
                 <a:solidFill>
-                  <a:srgbClr val="56645F"/>
+                  <a:srgbClr val="555F57"/>
                 </a:solidFill>
                 <a:latin typeface="Arial" pitchFamily="34" charset="0"/>
                 <a:ea typeface="Arial" pitchFamily="34" charset="-122"/>
@@ -8282,21 +8491,49 @@
             <a:r>
               <a:rPr lang="en-US" sz="800" b="1" spc="72" kern="0" dirty="0">
                 <a:solidFill>
-                  <a:srgbClr val="0E1F1A"/>
-                </a:solidFill>
-                <a:latin typeface="Arial" pitchFamily="34" charset="0"/>
-                <a:ea typeface="Arial" pitchFamily="34" charset="-122"/>
-                <a:cs typeface="Arial" pitchFamily="34" charset="-120"/>
-              </a:rPr>
-              <a:t>CAMP</a:t>
+                  <a:srgbClr val="0F8140"/>
+                </a:solidFill>
+                <a:latin typeface="Arial" pitchFamily="34" charset="0"/>
+                <a:ea typeface="Arial" pitchFamily="34" charset="-122"/>
+                <a:cs typeface="Arial" pitchFamily="34" charset="-120"/>
+              </a:rPr>
+              <a:t>C</a:t>
             </a:r>
             <a:pPr algn="l" indent="0" marL="0">
               <a:buNone/>
             </a:pPr>
             <a:r>
+              <a:rPr lang="en-US" sz="800" b="1" spc="72" kern="0" dirty="0">
+                <a:solidFill>
+                  <a:srgbClr val="A9C63C"/>
+                </a:solidFill>
+                <a:latin typeface="Arial" pitchFamily="34" charset="0"/>
+                <a:ea typeface="Arial" pitchFamily="34" charset="-122"/>
+                <a:cs typeface="Arial" pitchFamily="34" charset="-120"/>
+              </a:rPr>
+              <a:t>A</a:t>
+            </a:r>
+            <a:pPr algn="l" indent="0" marL="0">
+              <a:buNone/>
+            </a:pPr>
+            <a:r>
+              <a:rPr lang="en-US" sz="800" b="1" spc="72" kern="0" dirty="0">
+                <a:solidFill>
+                  <a:srgbClr val="0F8140"/>
+                </a:solidFill>
+                <a:latin typeface="Arial" pitchFamily="34" charset="0"/>
+                <a:ea typeface="Arial" pitchFamily="34" charset="-122"/>
+                <a:cs typeface="Arial" pitchFamily="34" charset="-120"/>
+              </a:rPr>
+              <a:t>MP</a:t>
+            </a:r>
+            <a:pPr algn="l" indent="0" marL="0">
+              <a:buNone/>
+            </a:pPr>
+            <a:r>
               <a:rPr lang="en-US" sz="800" spc="176" kern="0" dirty="0">
                 <a:solidFill>
-                  <a:srgbClr val="006A49"/>
+                  <a:srgbClr val="A9C63C"/>
                 </a:solidFill>
                 <a:latin typeface="Arial" pitchFamily="34" charset="0"/>
                 <a:ea typeface="Arial" pitchFamily="34" charset="-122"/>
@@ -8335,7 +8572,7 @@
             <a:r>
               <a:rPr lang="en-US" sz="800" b="1" spc="120" kern="0" dirty="0">
                 <a:solidFill>
-                  <a:srgbClr val="006A49"/>
+                  <a:srgbClr val="0F8140"/>
                 </a:solidFill>
                 <a:latin typeface="Arial" pitchFamily="34" charset="0"/>
                 <a:ea typeface="Arial" pitchFamily="34" charset="-122"/>
@@ -8361,7 +8598,7 @@
     <p:bg>
       <p:bgPr>
         <a:solidFill>
-          <a:srgbClr val="052C21"/>
+          <a:srgbClr val="06301A"/>
         </a:solidFill>
       </p:bgPr>
     </p:bg>
@@ -8461,11 +8698,11 @@
             </a:avLst>
           </a:prstGeom>
           <a:solidFill>
-            <a:srgbClr val="0A3A2C"/>
+            <a:srgbClr val="0B4526"/>
           </a:solidFill>
           <a:ln w="9525">
             <a:solidFill>
-              <a:srgbClr val="16513D"/>
+              <a:srgbClr val="1A5E34"/>
             </a:solidFill>
             <a:prstDash val="solid"/>
           </a:ln>
@@ -8498,7 +8735,7 @@
             <a:r>
               <a:rPr lang="en-US" sz="800" b="1" spc="70" kern="0" dirty="0">
                 <a:solidFill>
-                  <a:srgbClr val="7FDCBB"/>
+                  <a:srgbClr val="A9C63C"/>
                 </a:solidFill>
                 <a:latin typeface="Arial" pitchFamily="34" charset="0"/>
                 <a:ea typeface="Arial" pitchFamily="34" charset="-122"/>
@@ -8537,7 +8774,7 @@
             <a:r>
               <a:rPr lang="en-US" sz="4000" b="1" spc="-100" kern="0" dirty="0">
                 <a:solidFill>
-                  <a:srgbClr val="7FDCBB"/>
+                  <a:srgbClr val="A9C63C"/>
                 </a:solidFill>
                 <a:latin typeface="Arial" pitchFamily="34" charset="0"/>
                 <a:ea typeface="Arial" pitchFamily="34" charset="-122"/>
@@ -8618,7 +8855,7 @@
             <a:r>
               <a:rPr lang="en-US" sz="950" dirty="0">
                 <a:solidFill>
-                  <a:srgbClr val="9FC4B7"/>
+                  <a:srgbClr val="A8C09B"/>
                 </a:solidFill>
                 <a:latin typeface="Arial" pitchFamily="34" charset="0"/>
                 <a:ea typeface="Arial" pitchFamily="34" charset="-122"/>
@@ -8657,7 +8894,7 @@
             <a:r>
               <a:rPr lang="en-US" sz="4000" b="1" spc="-100" kern="0" dirty="0">
                 <a:solidFill>
-                  <a:srgbClr val="7FDCBB"/>
+                  <a:srgbClr val="A9C63C"/>
                 </a:solidFill>
                 <a:latin typeface="Arial" pitchFamily="34" charset="0"/>
                 <a:ea typeface="Arial" pitchFamily="34" charset="-122"/>
@@ -8738,7 +8975,7 @@
             <a:r>
               <a:rPr lang="en-US" sz="950" dirty="0">
                 <a:solidFill>
-                  <a:srgbClr val="9FC4B7"/>
+                  <a:srgbClr val="A8C09B"/>
                 </a:solidFill>
                 <a:latin typeface="Arial" pitchFamily="34" charset="0"/>
                 <a:ea typeface="Arial" pitchFamily="34" charset="-122"/>
@@ -8777,7 +9014,7 @@
             <a:r>
               <a:rPr lang="en-US" sz="4000" b="1" spc="-100" kern="0" dirty="0">
                 <a:solidFill>
-                  <a:srgbClr val="7FDCBB"/>
+                  <a:srgbClr val="A9C63C"/>
                 </a:solidFill>
                 <a:latin typeface="Arial" pitchFamily="34" charset="0"/>
                 <a:ea typeface="Arial" pitchFamily="34" charset="-122"/>
@@ -8858,7 +9095,7 @@
             <a:r>
               <a:rPr lang="en-US" sz="950" dirty="0">
                 <a:solidFill>
-                  <a:srgbClr val="9FC4B7"/>
+                  <a:srgbClr val="A8C09B"/>
                 </a:solidFill>
                 <a:latin typeface="Arial" pitchFamily="34" charset="0"/>
                 <a:ea typeface="Arial" pitchFamily="34" charset="-122"/>
@@ -8897,7 +9134,7 @@
             <a:r>
               <a:rPr lang="en-US" sz="4000" b="1" spc="-100" kern="0" dirty="0">
                 <a:solidFill>
-                  <a:srgbClr val="7FDCBB"/>
+                  <a:srgbClr val="A9C63C"/>
                 </a:solidFill>
                 <a:latin typeface="Arial" pitchFamily="34" charset="0"/>
                 <a:ea typeface="Arial" pitchFamily="34" charset="-122"/>
@@ -8978,7 +9215,7 @@
             <a:r>
               <a:rPr lang="en-US" sz="950" dirty="0">
                 <a:solidFill>
-                  <a:srgbClr val="9FC4B7"/>
+                  <a:srgbClr val="A8C09B"/>
                 </a:solidFill>
                 <a:latin typeface="Arial" pitchFamily="34" charset="0"/>
                 <a:ea typeface="Arial" pitchFamily="34" charset="-122"/>
@@ -9023,15 +9260,43 @@
                 <a:ea typeface="Arial" pitchFamily="34" charset="-122"/>
                 <a:cs typeface="Arial" pitchFamily="34" charset="-120"/>
               </a:rPr>
-              <a:t>CAMP</a:t>
+              <a:t>C</a:t>
             </a:r>
             <a:pPr algn="l" indent="0" marL="0">
               <a:buNone/>
             </a:pPr>
             <a:r>
+              <a:rPr lang="en-US" sz="800" b="1" spc="72" kern="0" dirty="0">
+                <a:solidFill>
+                  <a:srgbClr val="A9C63C"/>
+                </a:solidFill>
+                <a:latin typeface="Arial" pitchFamily="34" charset="0"/>
+                <a:ea typeface="Arial" pitchFamily="34" charset="-122"/>
+                <a:cs typeface="Arial" pitchFamily="34" charset="-120"/>
+              </a:rPr>
+              <a:t>A</a:t>
+            </a:r>
+            <a:pPr algn="l" indent="0" marL="0">
+              <a:buNone/>
+            </a:pPr>
+            <a:r>
+              <a:rPr lang="en-US" sz="800" b="1" spc="72" kern="0" dirty="0">
+                <a:solidFill>
+                  <a:srgbClr val="FFFFFF"/>
+                </a:solidFill>
+                <a:latin typeface="Arial" pitchFamily="34" charset="0"/>
+                <a:ea typeface="Arial" pitchFamily="34" charset="-122"/>
+                <a:cs typeface="Arial" pitchFamily="34" charset="-120"/>
+              </a:rPr>
+              <a:t>MP</a:t>
+            </a:r>
+            <a:pPr algn="l" indent="0" marL="0">
+              <a:buNone/>
+            </a:pPr>
+            <a:r>
               <a:rPr lang="en-US" sz="800" spc="176" kern="0" dirty="0">
                 <a:solidFill>
-                  <a:srgbClr val="7FDCBB"/>
+                  <a:srgbClr val="A9C63C"/>
                 </a:solidFill>
                 <a:latin typeface="Arial" pitchFamily="34" charset="0"/>
                 <a:ea typeface="Arial" pitchFamily="34" charset="-122"/>
@@ -9070,7 +9335,7 @@
             <a:r>
               <a:rPr lang="en-US" sz="800" b="1" spc="120" kern="0" dirty="0">
                 <a:solidFill>
-                  <a:srgbClr val="7FDCBB"/>
+                  <a:srgbClr val="A9C63C"/>
                 </a:solidFill>
                 <a:latin typeface="Arial" pitchFamily="34" charset="0"/>
                 <a:ea typeface="Arial" pitchFamily="34" charset="-122"/>
@@ -9144,7 +9409,7 @@
             <a:r>
               <a:rPr lang="en-US" sz="2700" b="1" spc="-40" kern="0" dirty="0">
                 <a:solidFill>
-                  <a:srgbClr val="0E1F1A"/>
+                  <a:srgbClr val="0D1F14"/>
                 </a:solidFill>
                 <a:latin typeface="Arial" pitchFamily="34" charset="0"/>
                 <a:ea typeface="Arial" pitchFamily="34" charset="-122"/>
@@ -9173,11 +9438,11 @@
             </a:avLst>
           </a:prstGeom>
           <a:solidFill>
-            <a:srgbClr val="F3F7F5"/>
+            <a:srgbClr val="F4F7F2"/>
           </a:solidFill>
           <a:ln w="9525">
             <a:solidFill>
-              <a:srgbClr val="DDE7E3"/>
+              <a:srgbClr val="DEE6DE"/>
             </a:solidFill>
             <a:prstDash val="solid"/>
           </a:ln>
@@ -9213,7 +9478,7 @@
             <a:r>
               <a:rPr lang="en-US" sz="1300" b="1" dirty="0">
                 <a:solidFill>
-                  <a:srgbClr val="56645F"/>
+                  <a:srgbClr val="555F57"/>
                 </a:solidFill>
                 <a:latin typeface="Arial" pitchFamily="34" charset="0"/>
                 <a:ea typeface="Arial" pitchFamily="34" charset="-122"/>
@@ -9275,7 +9540,7 @@
             <a:r>
               <a:rPr lang="en-US" sz="1050" dirty="0">
                 <a:solidFill>
-                  <a:srgbClr val="56645F"/>
+                  <a:srgbClr val="555F57"/>
                 </a:solidFill>
                 <a:latin typeface="Arial" pitchFamily="34" charset="0"/>
                 <a:ea typeface="Arial" pitchFamily="34" charset="-122"/>
@@ -9337,7 +9602,7 @@
             <a:r>
               <a:rPr lang="en-US" sz="1050" dirty="0">
                 <a:solidFill>
-                  <a:srgbClr val="56645F"/>
+                  <a:srgbClr val="555F57"/>
                 </a:solidFill>
                 <a:latin typeface="Arial" pitchFamily="34" charset="0"/>
                 <a:ea typeface="Arial" pitchFamily="34" charset="-122"/>
@@ -9399,7 +9664,7 @@
             <a:r>
               <a:rPr lang="en-US" sz="1050" dirty="0">
                 <a:solidFill>
-                  <a:srgbClr val="56645F"/>
+                  <a:srgbClr val="555F57"/>
                 </a:solidFill>
                 <a:latin typeface="Arial" pitchFamily="34" charset="0"/>
                 <a:ea typeface="Arial" pitchFamily="34" charset="-122"/>
@@ -9461,7 +9726,7 @@
             <a:r>
               <a:rPr lang="en-US" sz="1050" dirty="0">
                 <a:solidFill>
-                  <a:srgbClr val="56645F"/>
+                  <a:srgbClr val="555F57"/>
                 </a:solidFill>
                 <a:latin typeface="Arial" pitchFamily="34" charset="0"/>
                 <a:ea typeface="Arial" pitchFamily="34" charset="-122"/>
@@ -9490,11 +9755,11 @@
             </a:avLst>
           </a:prstGeom>
           <a:solidFill>
-            <a:srgbClr val="EDF7F3"/>
+            <a:srgbClr val="EEF5E4"/>
           </a:solidFill>
           <a:ln w="9525">
             <a:solidFill>
-              <a:srgbClr val="CDE8DE"/>
+              <a:srgbClr val="CFE2B8"/>
             </a:solidFill>
             <a:prstDash val="solid"/>
           </a:ln>
@@ -9530,7 +9795,7 @@
             <a:r>
               <a:rPr lang="en-US" sz="1300" b="1" dirty="0">
                 <a:solidFill>
-                  <a:srgbClr val="006A49"/>
+                  <a:srgbClr val="0F8140"/>
                 </a:solidFill>
                 <a:latin typeface="Arial" pitchFamily="34" charset="0"/>
                 <a:ea typeface="Arial" pitchFamily="34" charset="-122"/>
@@ -9596,7 +9861,7 @@
             <a:r>
               <a:rPr lang="en-US" sz="1050" dirty="0">
                 <a:solidFill>
-                  <a:srgbClr val="3F5B51"/>
+                  <a:srgbClr val="44543F"/>
                 </a:solidFill>
                 <a:latin typeface="Arial" pitchFamily="34" charset="0"/>
                 <a:ea typeface="Arial" pitchFamily="34" charset="-122"/>
@@ -9662,7 +9927,7 @@
             <a:r>
               <a:rPr lang="en-US" sz="1050" dirty="0">
                 <a:solidFill>
-                  <a:srgbClr val="3F5B51"/>
+                  <a:srgbClr val="44543F"/>
                 </a:solidFill>
                 <a:latin typeface="Arial" pitchFamily="34" charset="0"/>
                 <a:ea typeface="Arial" pitchFamily="34" charset="-122"/>
@@ -9728,7 +9993,7 @@
             <a:r>
               <a:rPr lang="en-US" sz="1050" dirty="0">
                 <a:solidFill>
-                  <a:srgbClr val="3F5B51"/>
+                  <a:srgbClr val="44543F"/>
                 </a:solidFill>
                 <a:latin typeface="Arial" pitchFamily="34" charset="0"/>
                 <a:ea typeface="Arial" pitchFamily="34" charset="-122"/>
@@ -9794,7 +10059,7 @@
             <a:r>
               <a:rPr lang="en-US" sz="1050" dirty="0">
                 <a:solidFill>
-                  <a:srgbClr val="3F5B51"/>
+                  <a:srgbClr val="44543F"/>
                 </a:solidFill>
                 <a:latin typeface="Arial" pitchFamily="34" charset="0"/>
                 <a:ea typeface="Arial" pitchFamily="34" charset="-122"/>
@@ -9823,14 +10088,9 @@
             </a:avLst>
           </a:prstGeom>
           <a:solidFill>
-            <a:srgbClr val="006A49"/>
+            <a:srgbClr val="0F8140"/>
           </a:solidFill>
-          <a:ln w="9525">
-            <a:solidFill>
-              <a:srgbClr val="006A49"/>
-            </a:solidFill>
-            <a:prstDash val="solid"/>
-          </a:ln>
+          <a:ln/>
         </p:spPr>
       </p:sp>
       <p:sp>
@@ -9902,21 +10162,49 @@
             <a:r>
               <a:rPr lang="en-US" sz="800" b="1" spc="72" kern="0" dirty="0">
                 <a:solidFill>
-                  <a:srgbClr val="0E1F1A"/>
-                </a:solidFill>
-                <a:latin typeface="Arial" pitchFamily="34" charset="0"/>
-                <a:ea typeface="Arial" pitchFamily="34" charset="-122"/>
-                <a:cs typeface="Arial" pitchFamily="34" charset="-120"/>
-              </a:rPr>
-              <a:t>CAMP</a:t>
+                  <a:srgbClr val="0F8140"/>
+                </a:solidFill>
+                <a:latin typeface="Arial" pitchFamily="34" charset="0"/>
+                <a:ea typeface="Arial" pitchFamily="34" charset="-122"/>
+                <a:cs typeface="Arial" pitchFamily="34" charset="-120"/>
+              </a:rPr>
+              <a:t>C</a:t>
             </a:r>
             <a:pPr algn="l" indent="0" marL="0">
               <a:buNone/>
             </a:pPr>
             <a:r>
+              <a:rPr lang="en-US" sz="800" b="1" spc="72" kern="0" dirty="0">
+                <a:solidFill>
+                  <a:srgbClr val="A9C63C"/>
+                </a:solidFill>
+                <a:latin typeface="Arial" pitchFamily="34" charset="0"/>
+                <a:ea typeface="Arial" pitchFamily="34" charset="-122"/>
+                <a:cs typeface="Arial" pitchFamily="34" charset="-120"/>
+              </a:rPr>
+              <a:t>A</a:t>
+            </a:r>
+            <a:pPr algn="l" indent="0" marL="0">
+              <a:buNone/>
+            </a:pPr>
+            <a:r>
+              <a:rPr lang="en-US" sz="800" b="1" spc="72" kern="0" dirty="0">
+                <a:solidFill>
+                  <a:srgbClr val="0F8140"/>
+                </a:solidFill>
+                <a:latin typeface="Arial" pitchFamily="34" charset="0"/>
+                <a:ea typeface="Arial" pitchFamily="34" charset="-122"/>
+                <a:cs typeface="Arial" pitchFamily="34" charset="-120"/>
+              </a:rPr>
+              <a:t>MP</a:t>
+            </a:r>
+            <a:pPr algn="l" indent="0" marL="0">
+              <a:buNone/>
+            </a:pPr>
+            <a:r>
               <a:rPr lang="en-US" sz="800" spc="176" kern="0" dirty="0">
                 <a:solidFill>
-                  <a:srgbClr val="006A49"/>
+                  <a:srgbClr val="A9C63C"/>
                 </a:solidFill>
                 <a:latin typeface="Arial" pitchFamily="34" charset="0"/>
                 <a:ea typeface="Arial" pitchFamily="34" charset="-122"/>
@@ -9955,7 +10243,7 @@
             <a:r>
               <a:rPr lang="en-US" sz="800" b="1" spc="120" kern="0" dirty="0">
                 <a:solidFill>
-                  <a:srgbClr val="006A49"/>
+                  <a:srgbClr val="0F8140"/>
                 </a:solidFill>
                 <a:latin typeface="Arial" pitchFamily="34" charset="0"/>
                 <a:ea typeface="Arial" pitchFamily="34" charset="-122"/>
@@ -10029,7 +10317,7 @@
             <a:r>
               <a:rPr lang="en-US" sz="2700" b="1" spc="-40" kern="0" dirty="0">
                 <a:solidFill>
-                  <a:srgbClr val="0E1F1A"/>
+                  <a:srgbClr val="0D1F14"/>
                 </a:solidFill>
                 <a:latin typeface="Arial" pitchFamily="34" charset="0"/>
                 <a:ea typeface="Arial" pitchFamily="34" charset="-122"/>
@@ -10058,7 +10346,7 @@
             </a:avLst>
           </a:prstGeom>
           <a:solidFill>
-            <a:srgbClr val="F3F7F5"/>
+            <a:srgbClr val="F4F7F2"/>
           </a:solidFill>
           <a:ln/>
         </p:spPr>
@@ -10116,7 +10404,7 @@
             <a:r>
               <a:rPr lang="en-US" sz="1250" b="1" dirty="0">
                 <a:solidFill>
-                  <a:srgbClr val="006A49"/>
+                  <a:srgbClr val="0F8140"/>
                 </a:solidFill>
                 <a:latin typeface="Arial" pitchFamily="34" charset="0"/>
                 <a:ea typeface="Arial" pitchFamily="34" charset="-122"/>
@@ -10158,7 +10446,7 @@
             <a:r>
               <a:rPr lang="en-US" sz="1050" dirty="0">
                 <a:solidFill>
-                  <a:srgbClr val="56645F"/>
+                  <a:srgbClr val="555F57"/>
                 </a:solidFill>
                 <a:latin typeface="Arial" pitchFamily="34" charset="0"/>
                 <a:ea typeface="Arial" pitchFamily="34" charset="-122"/>
@@ -10185,7 +10473,7 @@
             <a:avLst/>
           </a:prstGeom>
           <a:solidFill>
-            <a:srgbClr val="DDE7E3"/>
+            <a:srgbClr val="DEE6DE"/>
           </a:solidFill>
           <a:ln/>
         </p:spPr>
@@ -10220,7 +10508,7 @@
             <a:r>
               <a:rPr lang="en-US" sz="1250" b="1" dirty="0">
                 <a:solidFill>
-                  <a:srgbClr val="006A49"/>
+                  <a:srgbClr val="0F8140"/>
                 </a:solidFill>
                 <a:latin typeface="Arial" pitchFamily="34" charset="0"/>
                 <a:ea typeface="Arial" pitchFamily="34" charset="-122"/>
@@ -10262,7 +10550,7 @@
             <a:r>
               <a:rPr lang="en-US" sz="1050" dirty="0">
                 <a:solidFill>
-                  <a:srgbClr val="56645F"/>
+                  <a:srgbClr val="555F57"/>
                 </a:solidFill>
                 <a:latin typeface="Arial" pitchFamily="34" charset="0"/>
                 <a:ea typeface="Arial" pitchFamily="34" charset="-122"/>
@@ -10289,7 +10577,7 @@
             <a:avLst/>
           </a:prstGeom>
           <a:solidFill>
-            <a:srgbClr val="DDE7E3"/>
+            <a:srgbClr val="DEE6DE"/>
           </a:solidFill>
           <a:ln/>
         </p:spPr>
@@ -10324,7 +10612,7 @@
             <a:r>
               <a:rPr lang="en-US" sz="1250" b="1" dirty="0">
                 <a:solidFill>
-                  <a:srgbClr val="006A49"/>
+                  <a:srgbClr val="0F8140"/>
                 </a:solidFill>
                 <a:latin typeface="Arial" pitchFamily="34" charset="0"/>
                 <a:ea typeface="Arial" pitchFamily="34" charset="-122"/>
@@ -10366,7 +10654,7 @@
             <a:r>
               <a:rPr lang="en-US" sz="1050" dirty="0">
                 <a:solidFill>
-                  <a:srgbClr val="56645F"/>
+                  <a:srgbClr val="555F57"/>
                 </a:solidFill>
                 <a:latin typeface="Arial" pitchFamily="34" charset="0"/>
                 <a:ea typeface="Arial" pitchFamily="34" charset="-122"/>
@@ -10405,21 +10693,49 @@
             <a:r>
               <a:rPr lang="en-US" sz="800" b="1" spc="72" kern="0" dirty="0">
                 <a:solidFill>
-                  <a:srgbClr val="0E1F1A"/>
-                </a:solidFill>
-                <a:latin typeface="Arial" pitchFamily="34" charset="0"/>
-                <a:ea typeface="Arial" pitchFamily="34" charset="-122"/>
-                <a:cs typeface="Arial" pitchFamily="34" charset="-120"/>
-              </a:rPr>
-              <a:t>CAMP</a:t>
+                  <a:srgbClr val="0F8140"/>
+                </a:solidFill>
+                <a:latin typeface="Arial" pitchFamily="34" charset="0"/>
+                <a:ea typeface="Arial" pitchFamily="34" charset="-122"/>
+                <a:cs typeface="Arial" pitchFamily="34" charset="-120"/>
+              </a:rPr>
+              <a:t>C</a:t>
             </a:r>
             <a:pPr algn="l" indent="0" marL="0">
               <a:buNone/>
             </a:pPr>
             <a:r>
+              <a:rPr lang="en-US" sz="800" b="1" spc="72" kern="0" dirty="0">
+                <a:solidFill>
+                  <a:srgbClr val="A9C63C"/>
+                </a:solidFill>
+                <a:latin typeface="Arial" pitchFamily="34" charset="0"/>
+                <a:ea typeface="Arial" pitchFamily="34" charset="-122"/>
+                <a:cs typeface="Arial" pitchFamily="34" charset="-120"/>
+              </a:rPr>
+              <a:t>A</a:t>
+            </a:r>
+            <a:pPr algn="l" indent="0" marL="0">
+              <a:buNone/>
+            </a:pPr>
+            <a:r>
+              <a:rPr lang="en-US" sz="800" b="1" spc="72" kern="0" dirty="0">
+                <a:solidFill>
+                  <a:srgbClr val="0F8140"/>
+                </a:solidFill>
+                <a:latin typeface="Arial" pitchFamily="34" charset="0"/>
+                <a:ea typeface="Arial" pitchFamily="34" charset="-122"/>
+                <a:cs typeface="Arial" pitchFamily="34" charset="-120"/>
+              </a:rPr>
+              <a:t>MP</a:t>
+            </a:r>
+            <a:pPr algn="l" indent="0" marL="0">
+              <a:buNone/>
+            </a:pPr>
+            <a:r>
               <a:rPr lang="en-US" sz="800" spc="176" kern="0" dirty="0">
                 <a:solidFill>
-                  <a:srgbClr val="006A49"/>
+                  <a:srgbClr val="A9C63C"/>
                 </a:solidFill>
                 <a:latin typeface="Arial" pitchFamily="34" charset="0"/>
                 <a:ea typeface="Arial" pitchFamily="34" charset="-122"/>
@@ -10458,7 +10774,7 @@
             <a:r>
               <a:rPr lang="en-US" sz="800" b="1" spc="120" kern="0" dirty="0">
                 <a:solidFill>
-                  <a:srgbClr val="006A49"/>
+                  <a:srgbClr val="0F8140"/>
                 </a:solidFill>
                 <a:latin typeface="Arial" pitchFamily="34" charset="0"/>
                 <a:ea typeface="Arial" pitchFamily="34" charset="-122"/>

</xml_diff>